<commit_message>
feat: update veille technologique page to focus on NPU architectures with new content and presentation assets
</commit_message>
<xml_diff>
--- a/public/ppt/Stage BTS SIO SLAM - Wyze Academy.pptx
+++ b/public/ppt/Stage BTS SIO SLAM - Wyze Academy.pptx
@@ -1,26 +1,27 @@
 
 <file path=ppt/presentation.xml><?xml version="1.0" encoding="utf-8"?>
-<p:presentation xmlns:a="http://schemas.openxmlformats.org/drawingml/2006/main" xmlns:r="http://schemas.openxmlformats.org/officeDocument/2006/relationships" xmlns:p="http://schemas.openxmlformats.org/presentationml/2006/main" saveSubsetFonts="1" embedTrueTypeFonts="true">
+<p:presentation xmlns:a="http://schemas.openxmlformats.org/drawingml/2006/main" xmlns:r="http://schemas.openxmlformats.org/officeDocument/2006/relationships" xmlns:p="http://schemas.openxmlformats.org/presentationml/2006/main" embedTrueTypeFonts="1" saveSubsetFonts="1">
   <p:sldMasterIdLst>
     <p:sldMasterId id="2147483648" r:id="rId1"/>
   </p:sldMasterIdLst>
   <p:sldIdLst>
-    <p:sldId id="256" r:id="rId6"/>
-    <p:sldId id="257" r:id="rId7"/>
-    <p:sldId id="258" r:id="rId8"/>
-    <p:sldId id="259" r:id="rId9"/>
-    <p:sldId id="260" r:id="rId10"/>
+    <p:sldId id="256" r:id="rId2"/>
+    <p:sldId id="257" r:id="rId3"/>
+    <p:sldId id="258" r:id="rId4"/>
+    <p:sldId id="259" r:id="rId5"/>
+    <p:sldId id="260" r:id="rId6"/>
   </p:sldIdLst>
   <p:sldSz cx="18288000" cy="10287000"/>
   <p:notesSz cx="6858000" cy="9144000"/>
   <p:embeddedFontLst>
     <p:embeddedFont>
-      <p:font typeface="Open Sauce" charset="1" panose="00000500000000000000"/>
-      <p:regular r:id="rId11"/>
+      <p:font typeface="Open Sauce"/>
+      <p:regular r:id="rId7"/>
     </p:embeddedFont>
     <p:embeddedFont>
-      <p:font typeface="Open Sauce Bold" charset="1" panose="00000800000000000000"/>
-      <p:regular r:id="rId12"/>
+      <p:font typeface="Open Sauce Bold"/>
+      <p:regular r:id="rId8"/>
+      <p:bold r:id="rId9"/>
     </p:embeddedFont>
   </p:embeddedFontLst>
   <p:defaultTextStyle>
@@ -118,6 +119,22 @@
       </a:defRPr>
     </a:lvl9pPr>
   </p:defaultTextStyle>
+  <p:extLst>
+    <p:ext uri="{EFAFB233-063F-42B5-8137-9DF3F51BA10A}">
+      <p15:sldGuideLst xmlns:p15="http://schemas.microsoft.com/office/powerpoint/2012/main">
+        <p15:guide id="1" orient="horz" pos="2160">
+          <p15:clr>
+            <a:srgbClr val="A4A3A4"/>
+          </p15:clr>
+        </p15:guide>
+        <p15:guide id="2" pos="2880">
+          <p15:clr>
+            <a:srgbClr val="A4A3A4"/>
+          </p15:clr>
+        </p15:guide>
+      </p15:sldGuideLst>
+    </p:ext>
+  </p:extLst>
 </p:presentation>
 </file>
 
@@ -159,10 +176,9 @@
           <a:lstStyle/>
           <a:p>
             <a:r>
-              <a:rPr lang="en-US" smtClean="0"/>
+              <a:rPr lang="en-US"/>
               <a:t>Click to edit Master title style</a:t>
             </a:r>
-            <a:endParaRPr lang="en-US"/>
           </a:p>
         </p:txBody>
       </p:sp>
@@ -278,10 +294,9 @@
           </a:lstStyle>
           <a:p>
             <a:r>
-              <a:rPr lang="en-US" smtClean="0"/>
+              <a:rPr lang="en-US"/>
               <a:t>Click to edit Master subtitle style</a:t>
             </a:r>
-            <a:endParaRPr lang="en-US"/>
           </a:p>
         </p:txBody>
       </p:sp>
@@ -303,7 +318,7 @@
             <a:fld id="{1D8BD707-D9CF-40AE-B4C6-C98DA3205C09}" type="datetimeFigureOut">
               <a:rPr lang="en-US" smtClean="0"/>
               <a:pPr/>
-              <a:t>8/1/2011</a:t>
+              <a:t>5/12/26</a:t>
             </a:fld>
             <a:endParaRPr lang="en-US"/>
           </a:p>
@@ -346,7 +361,7 @@
             <a:fld id="{B6F15528-21DE-4FAA-801E-634DDDAF4B2B}" type="slidenum">
               <a:rPr lang="en-US" smtClean="0"/>
               <a:pPr/>
-              <a:t>‹#›</a:t>
+              <a:t>‹N°›</a:t>
             </a:fld>
             <a:endParaRPr lang="en-US"/>
           </a:p>
@@ -393,10 +408,9 @@
           <a:lstStyle/>
           <a:p>
             <a:r>
-              <a:rPr lang="en-US" smtClean="0"/>
+              <a:rPr lang="en-US"/>
               <a:t>Click to edit Master title style</a:t>
             </a:r>
-            <a:endParaRPr lang="en-US"/>
           </a:p>
         </p:txBody>
       </p:sp>
@@ -417,38 +431,37 @@
           <a:p>
             <a:pPr lvl="0"/>
             <a:r>
-              <a:rPr lang="en-US" smtClean="0"/>
+              <a:rPr lang="en-US"/>
               <a:t>Click to edit Master text styles</a:t>
             </a:r>
           </a:p>
           <a:p>
             <a:pPr lvl="1"/>
             <a:r>
-              <a:rPr lang="en-US" smtClean="0"/>
+              <a:rPr lang="en-US"/>
               <a:t>Second level</a:t>
             </a:r>
           </a:p>
           <a:p>
             <a:pPr lvl="2"/>
             <a:r>
-              <a:rPr lang="en-US" smtClean="0"/>
+              <a:rPr lang="en-US"/>
               <a:t>Third level</a:t>
             </a:r>
           </a:p>
           <a:p>
             <a:pPr lvl="3"/>
             <a:r>
-              <a:rPr lang="en-US" smtClean="0"/>
+              <a:rPr lang="en-US"/>
               <a:t>Fourth level</a:t>
             </a:r>
           </a:p>
           <a:p>
             <a:pPr lvl="4"/>
             <a:r>
-              <a:rPr lang="en-US" smtClean="0"/>
+              <a:rPr lang="en-US"/>
               <a:t>Fifth level</a:t>
             </a:r>
-            <a:endParaRPr lang="en-US"/>
           </a:p>
         </p:txBody>
       </p:sp>
@@ -470,7 +483,7 @@
             <a:fld id="{1D8BD707-D9CF-40AE-B4C6-C98DA3205C09}" type="datetimeFigureOut">
               <a:rPr lang="en-US" smtClean="0"/>
               <a:pPr/>
-              <a:t>8/1/2011</a:t>
+              <a:t>5/12/26</a:t>
             </a:fld>
             <a:endParaRPr lang="en-US"/>
           </a:p>
@@ -513,7 +526,7 @@
             <a:fld id="{B6F15528-21DE-4FAA-801E-634DDDAF4B2B}" type="slidenum">
               <a:rPr lang="en-US" smtClean="0"/>
               <a:pPr/>
-              <a:t>‹#›</a:t>
+              <a:t>‹N°›</a:t>
             </a:fld>
             <a:endParaRPr lang="en-US"/>
           </a:p>
@@ -565,10 +578,9 @@
           <a:lstStyle/>
           <a:p>
             <a:r>
-              <a:rPr lang="en-US" smtClean="0"/>
+              <a:rPr lang="en-US"/>
               <a:t>Click to edit Master title style</a:t>
             </a:r>
-            <a:endParaRPr lang="en-US"/>
           </a:p>
         </p:txBody>
       </p:sp>
@@ -594,38 +606,37 @@
           <a:p>
             <a:pPr lvl="0"/>
             <a:r>
-              <a:rPr lang="en-US" smtClean="0"/>
+              <a:rPr lang="en-US"/>
               <a:t>Click to edit Master text styles</a:t>
             </a:r>
           </a:p>
           <a:p>
             <a:pPr lvl="1"/>
             <a:r>
-              <a:rPr lang="en-US" smtClean="0"/>
+              <a:rPr lang="en-US"/>
               <a:t>Second level</a:t>
             </a:r>
           </a:p>
           <a:p>
             <a:pPr lvl="2"/>
             <a:r>
-              <a:rPr lang="en-US" smtClean="0"/>
+              <a:rPr lang="en-US"/>
               <a:t>Third level</a:t>
             </a:r>
           </a:p>
           <a:p>
             <a:pPr lvl="3"/>
             <a:r>
-              <a:rPr lang="en-US" smtClean="0"/>
+              <a:rPr lang="en-US"/>
               <a:t>Fourth level</a:t>
             </a:r>
           </a:p>
           <a:p>
             <a:pPr lvl="4"/>
             <a:r>
-              <a:rPr lang="en-US" smtClean="0"/>
+              <a:rPr lang="en-US"/>
               <a:t>Fifth level</a:t>
             </a:r>
-            <a:endParaRPr lang="en-US"/>
           </a:p>
         </p:txBody>
       </p:sp>
@@ -647,7 +658,7 @@
             <a:fld id="{1D8BD707-D9CF-40AE-B4C6-C98DA3205C09}" type="datetimeFigureOut">
               <a:rPr lang="en-US" smtClean="0"/>
               <a:pPr/>
-              <a:t>8/1/2011</a:t>
+              <a:t>5/12/26</a:t>
             </a:fld>
             <a:endParaRPr lang="en-US"/>
           </a:p>
@@ -690,7 +701,7 @@
             <a:fld id="{B6F15528-21DE-4FAA-801E-634DDDAF4B2B}" type="slidenum">
               <a:rPr lang="en-US" smtClean="0"/>
               <a:pPr/>
-              <a:t>‹#›</a:t>
+              <a:t>‹N°›</a:t>
             </a:fld>
             <a:endParaRPr lang="en-US"/>
           </a:p>
@@ -737,10 +748,9 @@
           <a:lstStyle/>
           <a:p>
             <a:r>
-              <a:rPr lang="en-US" smtClean="0"/>
+              <a:rPr lang="en-US"/>
               <a:t>Click to edit Master title style</a:t>
             </a:r>
-            <a:endParaRPr lang="en-US"/>
           </a:p>
         </p:txBody>
       </p:sp>
@@ -761,38 +771,37 @@
           <a:p>
             <a:pPr lvl="0"/>
             <a:r>
-              <a:rPr lang="en-US" smtClean="0"/>
+              <a:rPr lang="en-US"/>
               <a:t>Click to edit Master text styles</a:t>
             </a:r>
           </a:p>
           <a:p>
             <a:pPr lvl="1"/>
             <a:r>
-              <a:rPr lang="en-US" smtClean="0"/>
+              <a:rPr lang="en-US"/>
               <a:t>Second level</a:t>
             </a:r>
           </a:p>
           <a:p>
             <a:pPr lvl="2"/>
             <a:r>
-              <a:rPr lang="en-US" smtClean="0"/>
+              <a:rPr lang="en-US"/>
               <a:t>Third level</a:t>
             </a:r>
           </a:p>
           <a:p>
             <a:pPr lvl="3"/>
             <a:r>
-              <a:rPr lang="en-US" smtClean="0"/>
+              <a:rPr lang="en-US"/>
               <a:t>Fourth level</a:t>
             </a:r>
           </a:p>
           <a:p>
             <a:pPr lvl="4"/>
             <a:r>
-              <a:rPr lang="en-US" smtClean="0"/>
+              <a:rPr lang="en-US"/>
               <a:t>Fifth level</a:t>
             </a:r>
-            <a:endParaRPr lang="en-US"/>
           </a:p>
         </p:txBody>
       </p:sp>
@@ -814,7 +823,7 @@
             <a:fld id="{1D8BD707-D9CF-40AE-B4C6-C98DA3205C09}" type="datetimeFigureOut">
               <a:rPr lang="en-US" smtClean="0"/>
               <a:pPr/>
-              <a:t>8/1/2011</a:t>
+              <a:t>5/12/26</a:t>
             </a:fld>
             <a:endParaRPr lang="en-US"/>
           </a:p>
@@ -857,7 +866,7 @@
             <a:fld id="{B6F15528-21DE-4FAA-801E-634DDDAF4B2B}" type="slidenum">
               <a:rPr lang="en-US" smtClean="0"/>
               <a:pPr/>
-              <a:t>‹#›</a:t>
+              <a:t>‹N°›</a:t>
             </a:fld>
             <a:endParaRPr lang="en-US"/>
           </a:p>
@@ -913,10 +922,9 @@
           </a:lstStyle>
           <a:p>
             <a:r>
-              <a:rPr lang="en-US" smtClean="0"/>
+              <a:rPr lang="en-US"/>
               <a:t>Click to edit Master title style</a:t>
             </a:r>
-            <a:endParaRPr lang="en-US"/>
           </a:p>
         </p:txBody>
       </p:sp>
@@ -1033,7 +1041,7 @@
           <a:p>
             <a:pPr lvl="0"/>
             <a:r>
-              <a:rPr lang="en-US" smtClean="0"/>
+              <a:rPr lang="en-US"/>
               <a:t>Click to edit Master text styles</a:t>
             </a:r>
           </a:p>
@@ -1057,7 +1065,7 @@
             <a:fld id="{1D8BD707-D9CF-40AE-B4C6-C98DA3205C09}" type="datetimeFigureOut">
               <a:rPr lang="en-US" smtClean="0"/>
               <a:pPr/>
-              <a:t>8/1/2011</a:t>
+              <a:t>5/12/26</a:t>
             </a:fld>
             <a:endParaRPr lang="en-US"/>
           </a:p>
@@ -1100,7 +1108,7 @@
             <a:fld id="{B6F15528-21DE-4FAA-801E-634DDDAF4B2B}" type="slidenum">
               <a:rPr lang="en-US" smtClean="0"/>
               <a:pPr/>
-              <a:t>‹#›</a:t>
+              <a:t>‹N°›</a:t>
             </a:fld>
             <a:endParaRPr lang="en-US"/>
           </a:p>
@@ -1147,10 +1155,9 @@
           <a:lstStyle/>
           <a:p>
             <a:r>
-              <a:rPr lang="en-US" smtClean="0"/>
+              <a:rPr lang="en-US"/>
               <a:t>Click to edit Master title style</a:t>
             </a:r>
-            <a:endParaRPr lang="en-US"/>
           </a:p>
         </p:txBody>
       </p:sp>
@@ -1204,38 +1211,37 @@
           <a:p>
             <a:pPr lvl="0"/>
             <a:r>
-              <a:rPr lang="en-US" smtClean="0"/>
+              <a:rPr lang="en-US"/>
               <a:t>Click to edit Master text styles</a:t>
             </a:r>
           </a:p>
           <a:p>
             <a:pPr lvl="1"/>
             <a:r>
-              <a:rPr lang="en-US" smtClean="0"/>
+              <a:rPr lang="en-US"/>
               <a:t>Second level</a:t>
             </a:r>
           </a:p>
           <a:p>
             <a:pPr lvl="2"/>
             <a:r>
-              <a:rPr lang="en-US" smtClean="0"/>
+              <a:rPr lang="en-US"/>
               <a:t>Third level</a:t>
             </a:r>
           </a:p>
           <a:p>
             <a:pPr lvl="3"/>
             <a:r>
-              <a:rPr lang="en-US" smtClean="0"/>
+              <a:rPr lang="en-US"/>
               <a:t>Fourth level</a:t>
             </a:r>
           </a:p>
           <a:p>
             <a:pPr lvl="4"/>
             <a:r>
-              <a:rPr lang="en-US" smtClean="0"/>
+              <a:rPr lang="en-US"/>
               <a:t>Fifth level</a:t>
             </a:r>
-            <a:endParaRPr lang="en-US"/>
           </a:p>
         </p:txBody>
       </p:sp>
@@ -1289,38 +1295,37 @@
           <a:p>
             <a:pPr lvl="0"/>
             <a:r>
-              <a:rPr lang="en-US" smtClean="0"/>
+              <a:rPr lang="en-US"/>
               <a:t>Click to edit Master text styles</a:t>
             </a:r>
           </a:p>
           <a:p>
             <a:pPr lvl="1"/>
             <a:r>
-              <a:rPr lang="en-US" smtClean="0"/>
+              <a:rPr lang="en-US"/>
               <a:t>Second level</a:t>
             </a:r>
           </a:p>
           <a:p>
             <a:pPr lvl="2"/>
             <a:r>
-              <a:rPr lang="en-US" smtClean="0"/>
+              <a:rPr lang="en-US"/>
               <a:t>Third level</a:t>
             </a:r>
           </a:p>
           <a:p>
             <a:pPr lvl="3"/>
             <a:r>
-              <a:rPr lang="en-US" smtClean="0"/>
+              <a:rPr lang="en-US"/>
               <a:t>Fourth level</a:t>
             </a:r>
           </a:p>
           <a:p>
             <a:pPr lvl="4"/>
             <a:r>
-              <a:rPr lang="en-US" smtClean="0"/>
+              <a:rPr lang="en-US"/>
               <a:t>Fifth level</a:t>
             </a:r>
-            <a:endParaRPr lang="en-US"/>
           </a:p>
         </p:txBody>
       </p:sp>
@@ -1342,7 +1347,7 @@
             <a:fld id="{1D8BD707-D9CF-40AE-B4C6-C98DA3205C09}" type="datetimeFigureOut">
               <a:rPr lang="en-US" smtClean="0"/>
               <a:pPr/>
-              <a:t>8/1/2011</a:t>
+              <a:t>5/12/26</a:t>
             </a:fld>
             <a:endParaRPr lang="en-US"/>
           </a:p>
@@ -1385,7 +1390,7 @@
             <a:fld id="{B6F15528-21DE-4FAA-801E-634DDDAF4B2B}" type="slidenum">
               <a:rPr lang="en-US" smtClean="0"/>
               <a:pPr/>
-              <a:t>‹#›</a:t>
+              <a:t>‹N°›</a:t>
             </a:fld>
             <a:endParaRPr lang="en-US"/>
           </a:p>
@@ -1436,10 +1441,9 @@
           </a:lstStyle>
           <a:p>
             <a:r>
-              <a:rPr lang="en-US" smtClean="0"/>
+              <a:rPr lang="en-US"/>
               <a:t>Click to edit Master title style</a:t>
             </a:r>
-            <a:endParaRPr lang="en-US"/>
           </a:p>
         </p:txBody>
       </p:sp>
@@ -1502,7 +1506,7 @@
           <a:p>
             <a:pPr lvl="0"/>
             <a:r>
-              <a:rPr lang="en-US" smtClean="0"/>
+              <a:rPr lang="en-US"/>
               <a:t>Click to edit Master text styles</a:t>
             </a:r>
           </a:p>
@@ -1558,38 +1562,37 @@
           <a:p>
             <a:pPr lvl="0"/>
             <a:r>
-              <a:rPr lang="en-US" smtClean="0"/>
+              <a:rPr lang="en-US"/>
               <a:t>Click to edit Master text styles</a:t>
             </a:r>
           </a:p>
           <a:p>
             <a:pPr lvl="1"/>
             <a:r>
-              <a:rPr lang="en-US" smtClean="0"/>
+              <a:rPr lang="en-US"/>
               <a:t>Second level</a:t>
             </a:r>
           </a:p>
           <a:p>
             <a:pPr lvl="2"/>
             <a:r>
-              <a:rPr lang="en-US" smtClean="0"/>
+              <a:rPr lang="en-US"/>
               <a:t>Third level</a:t>
             </a:r>
           </a:p>
           <a:p>
             <a:pPr lvl="3"/>
             <a:r>
-              <a:rPr lang="en-US" smtClean="0"/>
+              <a:rPr lang="en-US"/>
               <a:t>Fourth level</a:t>
             </a:r>
           </a:p>
           <a:p>
             <a:pPr lvl="4"/>
             <a:r>
-              <a:rPr lang="en-US" smtClean="0"/>
+              <a:rPr lang="en-US"/>
               <a:t>Fifth level</a:t>
             </a:r>
-            <a:endParaRPr lang="en-US"/>
           </a:p>
         </p:txBody>
       </p:sp>
@@ -1652,7 +1655,7 @@
           <a:p>
             <a:pPr lvl="0"/>
             <a:r>
-              <a:rPr lang="en-US" smtClean="0"/>
+              <a:rPr lang="en-US"/>
               <a:t>Click to edit Master text styles</a:t>
             </a:r>
           </a:p>
@@ -1708,38 +1711,37 @@
           <a:p>
             <a:pPr lvl="0"/>
             <a:r>
-              <a:rPr lang="en-US" smtClean="0"/>
+              <a:rPr lang="en-US"/>
               <a:t>Click to edit Master text styles</a:t>
             </a:r>
           </a:p>
           <a:p>
             <a:pPr lvl="1"/>
             <a:r>
-              <a:rPr lang="en-US" smtClean="0"/>
+              <a:rPr lang="en-US"/>
               <a:t>Second level</a:t>
             </a:r>
           </a:p>
           <a:p>
             <a:pPr lvl="2"/>
             <a:r>
-              <a:rPr lang="en-US" smtClean="0"/>
+              <a:rPr lang="en-US"/>
               <a:t>Third level</a:t>
             </a:r>
           </a:p>
           <a:p>
             <a:pPr lvl="3"/>
             <a:r>
-              <a:rPr lang="en-US" smtClean="0"/>
+              <a:rPr lang="en-US"/>
               <a:t>Fourth level</a:t>
             </a:r>
           </a:p>
           <a:p>
             <a:pPr lvl="4"/>
             <a:r>
-              <a:rPr lang="en-US" smtClean="0"/>
+              <a:rPr lang="en-US"/>
               <a:t>Fifth level</a:t>
             </a:r>
-            <a:endParaRPr lang="en-US"/>
           </a:p>
         </p:txBody>
       </p:sp>
@@ -1761,7 +1763,7 @@
             <a:fld id="{1D8BD707-D9CF-40AE-B4C6-C98DA3205C09}" type="datetimeFigureOut">
               <a:rPr lang="en-US" smtClean="0"/>
               <a:pPr/>
-              <a:t>8/1/2011</a:t>
+              <a:t>5/12/26</a:t>
             </a:fld>
             <a:endParaRPr lang="en-US"/>
           </a:p>
@@ -1804,7 +1806,7 @@
             <a:fld id="{B6F15528-21DE-4FAA-801E-634DDDAF4B2B}" type="slidenum">
               <a:rPr lang="en-US" smtClean="0"/>
               <a:pPr/>
-              <a:t>‹#›</a:t>
+              <a:t>‹N°›</a:t>
             </a:fld>
             <a:endParaRPr lang="en-US"/>
           </a:p>
@@ -1851,10 +1853,9 @@
           <a:lstStyle/>
           <a:p>
             <a:r>
-              <a:rPr lang="en-US" smtClean="0"/>
+              <a:rPr lang="en-US"/>
               <a:t>Click to edit Master title style</a:t>
             </a:r>
-            <a:endParaRPr lang="en-US"/>
           </a:p>
         </p:txBody>
       </p:sp>
@@ -1876,7 +1877,7 @@
             <a:fld id="{1D8BD707-D9CF-40AE-B4C6-C98DA3205C09}" type="datetimeFigureOut">
               <a:rPr lang="en-US" smtClean="0"/>
               <a:pPr/>
-              <a:t>8/1/2011</a:t>
+              <a:t>5/12/26</a:t>
             </a:fld>
             <a:endParaRPr lang="en-US"/>
           </a:p>
@@ -1919,7 +1920,7 @@
             <a:fld id="{B6F15528-21DE-4FAA-801E-634DDDAF4B2B}" type="slidenum">
               <a:rPr lang="en-US" smtClean="0"/>
               <a:pPr/>
-              <a:t>‹#›</a:t>
+              <a:t>‹N°›</a:t>
             </a:fld>
             <a:endParaRPr lang="en-US"/>
           </a:p>
@@ -1968,7 +1969,7 @@
             <a:fld id="{1D8BD707-D9CF-40AE-B4C6-C98DA3205C09}" type="datetimeFigureOut">
               <a:rPr lang="en-US" smtClean="0"/>
               <a:pPr/>
-              <a:t>8/1/2011</a:t>
+              <a:t>5/12/26</a:t>
             </a:fld>
             <a:endParaRPr lang="en-US"/>
           </a:p>
@@ -2011,7 +2012,7 @@
             <a:fld id="{B6F15528-21DE-4FAA-801E-634DDDAF4B2B}" type="slidenum">
               <a:rPr lang="en-US" smtClean="0"/>
               <a:pPr/>
-              <a:t>‹#›</a:t>
+              <a:t>‹N°›</a:t>
             </a:fld>
             <a:endParaRPr lang="en-US"/>
           </a:p>
@@ -2067,10 +2068,9 @@
           </a:lstStyle>
           <a:p>
             <a:r>
-              <a:rPr lang="en-US" smtClean="0"/>
+              <a:rPr lang="en-US"/>
               <a:t>Click to edit Master title style</a:t>
             </a:r>
-            <a:endParaRPr lang="en-US"/>
           </a:p>
         </p:txBody>
       </p:sp>
@@ -2124,38 +2124,37 @@
           <a:p>
             <a:pPr lvl="0"/>
             <a:r>
-              <a:rPr lang="en-US" smtClean="0"/>
+              <a:rPr lang="en-US"/>
               <a:t>Click to edit Master text styles</a:t>
             </a:r>
           </a:p>
           <a:p>
             <a:pPr lvl="1"/>
             <a:r>
-              <a:rPr lang="en-US" smtClean="0"/>
+              <a:rPr lang="en-US"/>
               <a:t>Second level</a:t>
             </a:r>
           </a:p>
           <a:p>
             <a:pPr lvl="2"/>
             <a:r>
-              <a:rPr lang="en-US" smtClean="0"/>
+              <a:rPr lang="en-US"/>
               <a:t>Third level</a:t>
             </a:r>
           </a:p>
           <a:p>
             <a:pPr lvl="3"/>
             <a:r>
-              <a:rPr lang="en-US" smtClean="0"/>
+              <a:rPr lang="en-US"/>
               <a:t>Fourth level</a:t>
             </a:r>
           </a:p>
           <a:p>
             <a:pPr lvl="4"/>
             <a:r>
-              <a:rPr lang="en-US" smtClean="0"/>
+              <a:rPr lang="en-US"/>
               <a:t>Fifth level</a:t>
             </a:r>
-            <a:endParaRPr lang="en-US"/>
           </a:p>
         </p:txBody>
       </p:sp>
@@ -2218,7 +2217,7 @@
           <a:p>
             <a:pPr lvl="0"/>
             <a:r>
-              <a:rPr lang="en-US" smtClean="0"/>
+              <a:rPr lang="en-US"/>
               <a:t>Click to edit Master text styles</a:t>
             </a:r>
           </a:p>
@@ -2242,7 +2241,7 @@
             <a:fld id="{1D8BD707-D9CF-40AE-B4C6-C98DA3205C09}" type="datetimeFigureOut">
               <a:rPr lang="en-US" smtClean="0"/>
               <a:pPr/>
-              <a:t>8/1/2011</a:t>
+              <a:t>5/12/26</a:t>
             </a:fld>
             <a:endParaRPr lang="en-US"/>
           </a:p>
@@ -2285,7 +2284,7 @@
             <a:fld id="{B6F15528-21DE-4FAA-801E-634DDDAF4B2B}" type="slidenum">
               <a:rPr lang="en-US" smtClean="0"/>
               <a:pPr/>
-              <a:t>‹#›</a:t>
+              <a:t>‹N°›</a:t>
             </a:fld>
             <a:endParaRPr lang="en-US"/>
           </a:p>
@@ -2341,10 +2340,9 @@
           </a:lstStyle>
           <a:p>
             <a:r>
-              <a:rPr lang="en-US" smtClean="0"/>
+              <a:rPr lang="en-US"/>
               <a:t>Click to edit Master title style</a:t>
             </a:r>
-            <a:endParaRPr lang="en-US"/>
           </a:p>
         </p:txBody>
       </p:sp>
@@ -2468,7 +2466,7 @@
           <a:p>
             <a:pPr lvl="0"/>
             <a:r>
-              <a:rPr lang="en-US" smtClean="0"/>
+              <a:rPr lang="en-US"/>
               <a:t>Click to edit Master text styles</a:t>
             </a:r>
           </a:p>
@@ -2492,7 +2490,7 @@
             <a:fld id="{1D8BD707-D9CF-40AE-B4C6-C98DA3205C09}" type="datetimeFigureOut">
               <a:rPr lang="en-US" smtClean="0"/>
               <a:pPr/>
-              <a:t>8/1/2011</a:t>
+              <a:t>5/12/26</a:t>
             </a:fld>
             <a:endParaRPr lang="en-US"/>
           </a:p>
@@ -2535,7 +2533,7 @@
             <a:fld id="{B6F15528-21DE-4FAA-801E-634DDDAF4B2B}" type="slidenum">
               <a:rPr lang="en-US" smtClean="0"/>
               <a:pPr/>
-              <a:t>‹#›</a:t>
+              <a:t>‹N°›</a:t>
             </a:fld>
             <a:endParaRPr lang="en-US"/>
           </a:p>
@@ -2597,10 +2595,9 @@
           <a:lstStyle/>
           <a:p>
             <a:r>
-              <a:rPr lang="en-US" smtClean="0"/>
+              <a:rPr lang="en-US"/>
               <a:t>Click to edit Master title style</a:t>
             </a:r>
-            <a:endParaRPr lang="en-US"/>
           </a:p>
         </p:txBody>
       </p:sp>
@@ -2631,38 +2628,37 @@
           <a:p>
             <a:pPr lvl="0"/>
             <a:r>
-              <a:rPr lang="en-US" smtClean="0"/>
+              <a:rPr lang="en-US"/>
               <a:t>Click to edit Master text styles</a:t>
             </a:r>
           </a:p>
           <a:p>
             <a:pPr lvl="1"/>
             <a:r>
-              <a:rPr lang="en-US" smtClean="0"/>
+              <a:rPr lang="en-US"/>
               <a:t>Second level</a:t>
             </a:r>
           </a:p>
           <a:p>
             <a:pPr lvl="2"/>
             <a:r>
-              <a:rPr lang="en-US" smtClean="0"/>
+              <a:rPr lang="en-US"/>
               <a:t>Third level</a:t>
             </a:r>
           </a:p>
           <a:p>
             <a:pPr lvl="3"/>
             <a:r>
-              <a:rPr lang="en-US" smtClean="0"/>
+              <a:rPr lang="en-US"/>
               <a:t>Fourth level</a:t>
             </a:r>
           </a:p>
           <a:p>
             <a:pPr lvl="4"/>
             <a:r>
-              <a:rPr lang="en-US" smtClean="0"/>
+              <a:rPr lang="en-US"/>
               <a:t>Fifth level</a:t>
             </a:r>
-            <a:endParaRPr lang="en-US"/>
           </a:p>
         </p:txBody>
       </p:sp>
@@ -2702,7 +2698,7 @@
             <a:fld id="{1D8BD707-D9CF-40AE-B4C6-C98DA3205C09}" type="datetimeFigureOut">
               <a:rPr lang="en-US" smtClean="0"/>
               <a:pPr/>
-              <a:t>8/1/2011</a:t>
+              <a:t>5/12/26</a:t>
             </a:fld>
             <a:endParaRPr lang="en-US"/>
           </a:p>
@@ -2781,7 +2777,7 @@
             <a:fld id="{B6F15528-21DE-4FAA-801E-634DDDAF4B2B}" type="slidenum">
               <a:rPr lang="en-US" smtClean="0"/>
               <a:pPr/>
-              <a:t>‹#›</a:t>
+              <a:t>‹N°›</a:t>
             </a:fld>
             <a:endParaRPr lang="en-US"/>
           </a:p>
@@ -3057,13 +3053,14 @@
 </file>
 
 <file path=ppt/slides/slide1.xml><?xml version="1.0" encoding="utf-8"?>
-<p:sld xmlns:p="http://schemas.openxmlformats.org/presentationml/2006/main" xmlns:a="http://schemas.openxmlformats.org/drawingml/2006/main">
+<p:sld xmlns:a="http://schemas.openxmlformats.org/drawingml/2006/main" xmlns:r="http://schemas.openxmlformats.org/officeDocument/2006/relationships" xmlns:p="http://schemas.openxmlformats.org/presentationml/2006/main">
   <p:cSld>
     <p:bg>
       <p:bgPr>
         <a:solidFill>
           <a:srgbClr val="FAF7F0"/>
         </a:solidFill>
+        <a:effectLst/>
       </p:bgPr>
     </p:bg>
     <p:spTree>
@@ -3082,12 +3079,12 @@
       </p:grpSpPr>
       <p:sp>
         <p:nvSpPr>
-          <p:cNvPr name="TextBox 2" id="2"/>
-          <p:cNvSpPr txBox="true"/>
+          <p:cNvPr id="2" name="TextBox 2"/>
+          <p:cNvSpPr txBox="1"/>
           <p:nvPr/>
         </p:nvSpPr>
         <p:spPr>
-          <a:xfrm rot="0">
+          <a:xfrm>
             <a:off x="933450" y="2696608"/>
             <a:ext cx="10910528" cy="3386490"/>
           </a:xfrm>
@@ -3096,7 +3093,7 @@
           </a:prstGeom>
         </p:spPr>
         <p:txBody>
-          <a:bodyPr anchor="t" rtlCol="false" tIns="0" lIns="0" bIns="0" rIns="0">
+          <a:bodyPr lIns="0" tIns="0" rIns="0" bIns="0" rtlCol="0" anchor="t">
             <a:spAutoFit/>
           </a:bodyPr>
           <a:lstStyle/>
@@ -3123,12 +3120,12 @@
       </p:sp>
       <p:sp>
         <p:nvSpPr>
-          <p:cNvPr name="TextBox 3" id="3"/>
-          <p:cNvSpPr txBox="true"/>
+          <p:cNvPr id="3" name="TextBox 3"/>
+          <p:cNvSpPr txBox="1"/>
           <p:nvPr/>
         </p:nvSpPr>
         <p:spPr>
-          <a:xfrm rot="0">
+          <a:xfrm>
             <a:off x="8281152" y="7388071"/>
             <a:ext cx="8978148" cy="762000"/>
           </a:xfrm>
@@ -3137,7 +3134,7 @@
           </a:prstGeom>
         </p:spPr>
         <p:txBody>
-          <a:bodyPr anchor="t" rtlCol="false" tIns="0" lIns="0" bIns="0" rIns="0">
+          <a:bodyPr lIns="0" tIns="0" rIns="0" bIns="0" rtlCol="0" anchor="t">
             <a:spAutoFit/>
           </a:bodyPr>
           <a:lstStyle/>
@@ -3148,7 +3145,7 @@
               </a:lnSpc>
             </a:pPr>
             <a:r>
-              <a:rPr lang="en-US" b="true" sz="2999" spc="299">
+              <a:rPr lang="en-US" sz="2999" b="1" spc="299" dirty="0">
                 <a:solidFill>
                   <a:srgbClr val="8C7753"/>
                 </a:solidFill>
@@ -3170,7 +3167,7 @@
               </a:spcBef>
             </a:pPr>
             <a:r>
-              <a:rPr lang="en-US" b="true" sz="2999" spc="299">
+              <a:rPr lang="en-US" sz="2999" b="1" spc="299" dirty="0">
                 <a:solidFill>
                   <a:srgbClr val="8C7753"/>
                 </a:solidFill>
@@ -3179,19 +3176,19 @@
                 <a:cs typeface="Open Sauce Bold"/>
                 <a:sym typeface="Open Sauce Bold"/>
               </a:rPr>
-              <a:t>PÉRIODE: DÉCEMBRE 2026</a:t>
-            </a:r>
-          </a:p>
-        </p:txBody>
-      </p:sp>
-      <p:sp>
-        <p:nvSpPr>
-          <p:cNvPr name="TextBox 4" id="4"/>
-          <p:cNvSpPr txBox="true"/>
+              <a:t>PÉRIODE: DÉCEMBRE 2025</a:t>
+            </a:r>
+          </a:p>
+        </p:txBody>
+      </p:sp>
+      <p:sp>
+        <p:nvSpPr>
+          <p:cNvPr id="4" name="TextBox 4"/>
+          <p:cNvSpPr txBox="1"/>
           <p:nvPr/>
         </p:nvSpPr>
         <p:spPr>
-          <a:xfrm rot="0">
+          <a:xfrm>
             <a:off x="1028700" y="1057275"/>
             <a:ext cx="4560684" cy="245745"/>
           </a:xfrm>
@@ -3200,7 +3197,7 @@
           </a:prstGeom>
         </p:spPr>
         <p:txBody>
-          <a:bodyPr anchor="t" rtlCol="false" tIns="0" lIns="0" bIns="0" rIns="0">
+          <a:bodyPr lIns="0" tIns="0" rIns="0" bIns="0" rtlCol="0" anchor="t">
             <a:spAutoFit/>
           </a:bodyPr>
           <a:lstStyle/>
@@ -3214,7 +3211,7 @@
               </a:spcBef>
             </a:pPr>
             <a:r>
-              <a:rPr lang="en-US" b="true" sz="1800" spc="179">
+              <a:rPr lang="en-US" sz="1800" b="1" spc="179">
                 <a:solidFill>
                   <a:srgbClr val="8C7753"/>
                 </a:solidFill>
@@ -3230,12 +3227,12 @@
       </p:sp>
       <p:sp>
         <p:nvSpPr>
-          <p:cNvPr name="TextBox 5" id="5"/>
-          <p:cNvSpPr txBox="true"/>
+          <p:cNvPr id="5" name="TextBox 5"/>
+          <p:cNvSpPr txBox="1"/>
           <p:nvPr/>
         </p:nvSpPr>
         <p:spPr>
-          <a:xfrm rot="0">
+          <a:xfrm>
             <a:off x="933450" y="6121198"/>
             <a:ext cx="8978148" cy="327660"/>
           </a:xfrm>
@@ -3244,7 +3241,7 @@
           </a:prstGeom>
         </p:spPr>
         <p:txBody>
-          <a:bodyPr anchor="t" rtlCol="false" tIns="0" lIns="0" bIns="0" rIns="0">
+          <a:bodyPr lIns="0" tIns="0" rIns="0" bIns="0" rtlCol="0" anchor="t">
             <a:spAutoFit/>
           </a:bodyPr>
           <a:lstStyle/>
@@ -3258,7 +3255,7 @@
               </a:spcBef>
             </a:pPr>
             <a:r>
-              <a:rPr lang="en-US" b="true" sz="2400" spc="240">
+              <a:rPr lang="en-US" sz="2400" b="1" spc="240">
                 <a:gradFill>
                   <a:gsLst>
                     <a:gs pos="0">
@@ -3293,7 +3290,7 @@
 </file>
 
 <file path=ppt/slides/slide2.xml><?xml version="1.0" encoding="utf-8"?>
-<p:sld xmlns:p="http://schemas.openxmlformats.org/presentationml/2006/main" xmlns:a="http://schemas.openxmlformats.org/drawingml/2006/main" xmlns:r="http://schemas.openxmlformats.org/officeDocument/2006/relationships">
+<p:sld xmlns:a="http://schemas.openxmlformats.org/drawingml/2006/main" xmlns:r="http://schemas.openxmlformats.org/officeDocument/2006/relationships" xmlns:p="http://schemas.openxmlformats.org/presentationml/2006/main">
   <p:cSld>
     <p:spTree>
       <p:nvGrpSpPr>
@@ -3311,12 +3308,12 @@
       </p:grpSpPr>
       <p:grpSp>
         <p:nvGrpSpPr>
-          <p:cNvPr name="Group 2" id="2"/>
+          <p:cNvPr id="2" name="Group 2"/>
           <p:cNvGrpSpPr/>
           <p:nvPr/>
         </p:nvGrpSpPr>
         <p:grpSpPr>
-          <a:xfrm rot="0">
+          <a:xfrm>
             <a:off x="6935932" y="2790553"/>
             <a:ext cx="4017818" cy="1296346"/>
             <a:chOff x="0" y="0"/>
@@ -3325,12 +3322,12 @@
         </p:grpSpPr>
         <p:sp>
           <p:nvSpPr>
-            <p:cNvPr name="Freeform 3" id="3"/>
+            <p:cNvPr id="3" name="Freeform 3"/>
             <p:cNvSpPr/>
             <p:nvPr/>
           </p:nvSpPr>
           <p:spPr>
-            <a:xfrm flipH="false" flipV="false" rot="0">
+            <a:xfrm>
               <a:off x="0" y="0"/>
               <a:ext cx="1058191" cy="341425"/>
             </a:xfrm>
@@ -3339,9 +3336,9 @@
               <a:gdLst/>
               <a:ahLst/>
               <a:cxnLst/>
-              <a:rect r="r" b="b" t="t" l="l"/>
+              <a:rect l="l" t="t" r="r" b="b"/>
               <a:pathLst>
-                <a:path h="341425" w="1058191">
+                <a:path w="1058191" h="341425">
                   <a:moveTo>
                     <a:pt x="67441" y="0"/>
                   </a:moveTo>
@@ -3386,7 +3383,7 @@
                 </a:path>
               </a:pathLst>
             </a:custGeom>
-            <a:gradFill rotWithShape="true">
+            <a:gradFill rotWithShape="1">
               <a:gsLst>
                 <a:gs pos="0">
                   <a:srgbClr val="DFDFDF">
@@ -3407,11 +3404,18 @@
               <a:round/>
             </a:ln>
           </p:spPr>
+          <p:txBody>
+            <a:bodyPr/>
+            <a:lstStyle/>
+            <a:p>
+              <a:endParaRPr lang="fr-FR"/>
+            </a:p>
+          </p:txBody>
         </p:sp>
         <p:sp>
           <p:nvSpPr>
-            <p:cNvPr name="TextBox 4" id="4"/>
-            <p:cNvSpPr txBox="true"/>
+            <p:cNvPr id="4" name="TextBox 4"/>
+            <p:cNvSpPr txBox="1"/>
             <p:nvPr/>
           </p:nvSpPr>
           <p:spPr>
@@ -3424,7 +3428,7 @@
             </a:prstGeom>
           </p:spPr>
           <p:txBody>
-            <a:bodyPr anchor="ctr" rtlCol="false" tIns="50800" lIns="50800" bIns="50800" rIns="50800"/>
+            <a:bodyPr lIns="50800" tIns="50800" rIns="50800" bIns="50800" rtlCol="0" anchor="ctr"/>
             <a:lstStyle/>
             <a:p>
               <a:pPr algn="ctr">
@@ -3433,7 +3437,7 @@
                 </a:lnSpc>
               </a:pPr>
               <a:r>
-                <a:rPr lang="en-US" sz="2400">
+                <a:rPr lang="en-US" sz="2400" dirty="0">
                   <a:solidFill>
                     <a:srgbClr val="000000"/>
                   </a:solidFill>
@@ -3452,7 +3456,7 @@
                 </a:lnSpc>
               </a:pPr>
               <a:r>
-                <a:rPr lang="en-US" sz="1900">
+                <a:rPr lang="en-US" sz="1900" dirty="0">
                   <a:solidFill>
                     <a:srgbClr val="000000"/>
                   </a:solidFill>
@@ -3469,7 +3473,7 @@
       </p:grpSp>
       <p:sp>
         <p:nvSpPr>
-          <p:cNvPr name="AutoShape 5" id="5"/>
+          <p:cNvPr id="5" name="AutoShape 5"/>
           <p:cNvSpPr/>
           <p:nvPr/>
         </p:nvSpPr>
@@ -3481,24 +3485,31 @@
           <a:prstGeom prst="line">
             <a:avLst/>
           </a:prstGeom>
-          <a:ln cap="flat" w="28575">
+          <a:ln w="28575" cap="flat">
             <a:solidFill>
               <a:srgbClr val="000000"/>
             </a:solidFill>
             <a:prstDash val="sysDash"/>
-            <a:headEnd type="none" len="sm" w="sm"/>
-            <a:tailEnd type="triangle" len="med" w="lg"/>
+            <a:headEnd type="none" w="sm" len="sm"/>
+            <a:tailEnd type="triangle" w="lg" len="med"/>
           </a:ln>
         </p:spPr>
+        <p:txBody>
+          <a:bodyPr/>
+          <a:lstStyle/>
+          <a:p>
+            <a:endParaRPr lang="fr-FR"/>
+          </a:p>
+        </p:txBody>
       </p:sp>
       <p:grpSp>
         <p:nvGrpSpPr>
-          <p:cNvPr name="Group 6" id="6"/>
+          <p:cNvPr id="6" name="Group 6"/>
           <p:cNvGrpSpPr/>
           <p:nvPr/>
         </p:nvGrpSpPr>
         <p:grpSpPr>
-          <a:xfrm rot="0">
+          <a:xfrm>
             <a:off x="14439900" y="7186669"/>
             <a:ext cx="2501611" cy="1469924"/>
             <a:chOff x="0" y="0"/>
@@ -3507,12 +3518,12 @@
         </p:grpSpPr>
         <p:sp>
           <p:nvSpPr>
-            <p:cNvPr name="Freeform 7" id="7"/>
+            <p:cNvPr id="7" name="Freeform 7"/>
             <p:cNvSpPr/>
             <p:nvPr/>
           </p:nvSpPr>
           <p:spPr>
-            <a:xfrm flipH="false" flipV="false" rot="0">
+            <a:xfrm>
               <a:off x="0" y="0"/>
               <a:ext cx="658861" cy="387140"/>
             </a:xfrm>
@@ -3521,9 +3532,9 @@
               <a:gdLst/>
               <a:ahLst/>
               <a:cxnLst/>
-              <a:rect r="r" b="b" t="t" l="l"/>
+              <a:rect l="l" t="t" r="r" b="b"/>
               <a:pathLst>
-                <a:path h="387140" w="658861">
+                <a:path w="658861" h="387140">
                   <a:moveTo>
                     <a:pt x="108317" y="0"/>
                   </a:moveTo>
@@ -3583,7 +3594,7 @@
                 </a:path>
               </a:pathLst>
             </a:custGeom>
-            <a:gradFill rotWithShape="true">
+            <a:gradFill rotWithShape="1">
               <a:gsLst>
                 <a:gs pos="0">
                   <a:srgbClr val="DFDFDF">
@@ -3604,11 +3615,18 @@
               <a:round/>
             </a:ln>
           </p:spPr>
+          <p:txBody>
+            <a:bodyPr/>
+            <a:lstStyle/>
+            <a:p>
+              <a:endParaRPr lang="fr-FR"/>
+            </a:p>
+          </p:txBody>
         </p:sp>
         <p:sp>
           <p:nvSpPr>
-            <p:cNvPr name="TextBox 8" id="8"/>
-            <p:cNvSpPr txBox="true"/>
+            <p:cNvPr id="8" name="TextBox 8"/>
+            <p:cNvSpPr txBox="1"/>
             <p:nvPr/>
           </p:nvSpPr>
           <p:spPr>
@@ -3621,7 +3639,7 @@
             </a:prstGeom>
           </p:spPr>
           <p:txBody>
-            <a:bodyPr anchor="ctr" rtlCol="false" tIns="50800" lIns="50800" bIns="50800" rIns="50800"/>
+            <a:bodyPr lIns="50800" tIns="50800" rIns="50800" bIns="50800" rtlCol="0" anchor="ctr"/>
             <a:lstStyle/>
             <a:p>
               <a:pPr algn="ctr">
@@ -3666,12 +3684,12 @@
       </p:grpSp>
       <p:grpSp>
         <p:nvGrpSpPr>
-          <p:cNvPr name="Group 9" id="9"/>
+          <p:cNvPr id="9" name="Group 9"/>
           <p:cNvGrpSpPr/>
           <p:nvPr/>
         </p:nvGrpSpPr>
         <p:grpSpPr>
-          <a:xfrm rot="0">
+          <a:xfrm>
             <a:off x="13335866" y="2790553"/>
             <a:ext cx="3605645" cy="1296346"/>
             <a:chOff x="0" y="0"/>
@@ -3680,12 +3698,12 @@
         </p:grpSpPr>
         <p:sp>
           <p:nvSpPr>
-            <p:cNvPr name="Freeform 10" id="10"/>
+            <p:cNvPr id="10" name="Freeform 10"/>
             <p:cNvSpPr/>
             <p:nvPr/>
           </p:nvSpPr>
           <p:spPr>
-            <a:xfrm flipH="false" flipV="false" rot="0">
+            <a:xfrm>
               <a:off x="0" y="0"/>
               <a:ext cx="949635" cy="341425"/>
             </a:xfrm>
@@ -3694,9 +3712,9 @@
               <a:gdLst/>
               <a:ahLst/>
               <a:cxnLst/>
-              <a:rect r="r" b="b" t="t" l="l"/>
+              <a:rect l="l" t="t" r="r" b="b"/>
               <a:pathLst>
-                <a:path h="341425" w="949635">
+                <a:path w="949635" h="341425">
                   <a:moveTo>
                     <a:pt x="75151" y="0"/>
                   </a:moveTo>
@@ -3736,7 +3754,7 @@
                 </a:path>
               </a:pathLst>
             </a:custGeom>
-            <a:gradFill rotWithShape="true">
+            <a:gradFill rotWithShape="1">
               <a:gsLst>
                 <a:gs pos="0">
                   <a:srgbClr val="DFDFDF">
@@ -3757,11 +3775,18 @@
               <a:round/>
             </a:ln>
           </p:spPr>
+          <p:txBody>
+            <a:bodyPr/>
+            <a:lstStyle/>
+            <a:p>
+              <a:endParaRPr lang="fr-FR"/>
+            </a:p>
+          </p:txBody>
         </p:sp>
         <p:sp>
           <p:nvSpPr>
-            <p:cNvPr name="TextBox 11" id="11"/>
-            <p:cNvSpPr txBox="true"/>
+            <p:cNvPr id="11" name="TextBox 11"/>
+            <p:cNvSpPr txBox="1"/>
             <p:nvPr/>
           </p:nvSpPr>
           <p:spPr>
@@ -3774,7 +3799,7 @@
             </a:prstGeom>
           </p:spPr>
           <p:txBody>
-            <a:bodyPr anchor="ctr" rtlCol="false" tIns="50800" lIns="50800" bIns="50800" rIns="50800"/>
+            <a:bodyPr lIns="50800" tIns="50800" rIns="50800" bIns="50800" rtlCol="0" anchor="ctr"/>
             <a:lstStyle/>
             <a:p>
               <a:pPr algn="ctr">
@@ -3819,12 +3844,12 @@
       </p:grpSp>
       <p:grpSp>
         <p:nvGrpSpPr>
-          <p:cNvPr name="Group 12" id="12"/>
+          <p:cNvPr id="12" name="Group 12"/>
           <p:cNvGrpSpPr/>
           <p:nvPr/>
         </p:nvGrpSpPr>
         <p:grpSpPr>
-          <a:xfrm rot="0">
+          <a:xfrm>
             <a:off x="10695709" y="4723342"/>
             <a:ext cx="3345873" cy="1266070"/>
             <a:chOff x="0" y="0"/>
@@ -3833,12 +3858,12 @@
         </p:grpSpPr>
         <p:sp>
           <p:nvSpPr>
-            <p:cNvPr name="Freeform 13" id="13"/>
+            <p:cNvPr id="13" name="Freeform 13"/>
             <p:cNvSpPr/>
             <p:nvPr/>
           </p:nvSpPr>
           <p:spPr>
-            <a:xfrm flipH="false" flipV="false" rot="0">
+            <a:xfrm>
               <a:off x="0" y="0"/>
               <a:ext cx="881218" cy="333450"/>
             </a:xfrm>
@@ -3847,9 +3872,9 @@
               <a:gdLst/>
               <a:ahLst/>
               <a:cxnLst/>
-              <a:rect r="r" b="b" t="t" l="l"/>
+              <a:rect l="l" t="t" r="r" b="b"/>
               <a:pathLst>
-                <a:path h="333450" w="881218">
+                <a:path w="881218" h="333450">
                   <a:moveTo>
                     <a:pt x="80986" y="0"/>
                   </a:moveTo>
@@ -3909,7 +3934,7 @@
                 </a:path>
               </a:pathLst>
             </a:custGeom>
-            <a:gradFill rotWithShape="true">
+            <a:gradFill rotWithShape="1">
               <a:gsLst>
                 <a:gs pos="0">
                   <a:srgbClr val="DFDFDF">
@@ -3930,11 +3955,18 @@
               <a:round/>
             </a:ln>
           </p:spPr>
+          <p:txBody>
+            <a:bodyPr/>
+            <a:lstStyle/>
+            <a:p>
+              <a:endParaRPr lang="fr-FR"/>
+            </a:p>
+          </p:txBody>
         </p:sp>
         <p:sp>
           <p:nvSpPr>
-            <p:cNvPr name="TextBox 14" id="14"/>
-            <p:cNvSpPr txBox="true"/>
+            <p:cNvPr id="14" name="TextBox 14"/>
+            <p:cNvSpPr txBox="1"/>
             <p:nvPr/>
           </p:nvSpPr>
           <p:spPr>
@@ -3947,7 +3979,7 @@
             </a:prstGeom>
           </p:spPr>
           <p:txBody>
-            <a:bodyPr anchor="ctr" rtlCol="false" tIns="50800" lIns="50800" bIns="50800" rIns="50800"/>
+            <a:bodyPr lIns="50800" tIns="50800" rIns="50800" bIns="50800" rtlCol="0" anchor="ctr"/>
             <a:lstStyle/>
             <a:p>
               <a:pPr algn="ctr">
@@ -3956,7 +3988,7 @@
                 </a:lnSpc>
               </a:pPr>
               <a:r>
-                <a:rPr lang="en-US" sz="2400">
+                <a:rPr lang="en-US" sz="2400" dirty="0">
                   <a:solidFill>
                     <a:srgbClr val="000000"/>
                   </a:solidFill>
@@ -3975,7 +4007,7 @@
                 </a:lnSpc>
               </a:pPr>
               <a:r>
-                <a:rPr lang="en-US" sz="1900">
+                <a:rPr lang="en-US" sz="1900" dirty="0">
                   <a:solidFill>
                     <a:srgbClr val="000000"/>
                   </a:solidFill>
@@ -3992,7 +4024,7 @@
       </p:grpSp>
       <p:sp>
         <p:nvSpPr>
-          <p:cNvPr name="AutoShape 15" id="15"/>
+          <p:cNvPr id="15" name="AutoShape 15"/>
           <p:cNvSpPr/>
           <p:nvPr/>
         </p:nvSpPr>
@@ -4004,48 +4036,62 @@
           <a:prstGeom prst="line">
             <a:avLst/>
           </a:prstGeom>
-          <a:ln cap="flat" w="28575">
+          <a:ln w="28575" cap="flat">
             <a:solidFill>
               <a:srgbClr val="000000"/>
             </a:solidFill>
             <a:prstDash val="sysDash"/>
-            <a:headEnd type="none" len="sm" w="sm"/>
-            <a:tailEnd type="triangle" len="med" w="lg"/>
+            <a:headEnd type="none" w="sm" len="sm"/>
+            <a:tailEnd type="triangle" w="lg" len="med"/>
           </a:ln>
         </p:spPr>
-      </p:sp>
-      <p:sp>
-        <p:nvSpPr>
-          <p:cNvPr name="AutoShape 16" id="16"/>
+        <p:txBody>
+          <a:bodyPr/>
+          <a:lstStyle/>
+          <a:p>
+            <a:endParaRPr lang="fr-FR"/>
+          </a:p>
+        </p:txBody>
+      </p:sp>
+      <p:sp>
+        <p:nvSpPr>
+          <p:cNvPr id="16" name="AutoShape 16"/>
           <p:cNvSpPr/>
           <p:nvPr/>
         </p:nvSpPr>
         <p:spPr>
-          <a:xfrm flipH="true">
+          <a:xfrm flipH="1">
             <a:off x="12368645" y="4086899"/>
             <a:ext cx="2770043" cy="636443"/>
           </a:xfrm>
           <a:prstGeom prst="line">
             <a:avLst/>
           </a:prstGeom>
-          <a:ln cap="flat" w="28575">
+          <a:ln w="28575" cap="flat">
             <a:solidFill>
               <a:srgbClr val="000000"/>
             </a:solidFill>
             <a:prstDash val="sysDash"/>
-            <a:headEnd type="none" len="sm" w="sm"/>
-            <a:tailEnd type="triangle" len="med" w="lg"/>
+            <a:headEnd type="none" w="sm" len="sm"/>
+            <a:tailEnd type="triangle" w="lg" len="med"/>
           </a:ln>
         </p:spPr>
+        <p:txBody>
+          <a:bodyPr/>
+          <a:lstStyle/>
+          <a:p>
+            <a:endParaRPr lang="fr-FR"/>
+          </a:p>
+        </p:txBody>
       </p:sp>
       <p:grpSp>
         <p:nvGrpSpPr>
-          <p:cNvPr name="Group 17" id="17"/>
+          <p:cNvPr id="17" name="Group 17"/>
           <p:cNvGrpSpPr/>
           <p:nvPr/>
         </p:nvGrpSpPr>
         <p:grpSpPr>
-          <a:xfrm rot="0">
+          <a:xfrm>
             <a:off x="11001706" y="7186669"/>
             <a:ext cx="2733878" cy="1469924"/>
             <a:chOff x="0" y="0"/>
@@ -4054,12 +4100,12 @@
         </p:grpSpPr>
         <p:sp>
           <p:nvSpPr>
-            <p:cNvPr name="Freeform 18" id="18"/>
+            <p:cNvPr id="18" name="Freeform 18"/>
             <p:cNvSpPr/>
             <p:nvPr/>
           </p:nvSpPr>
           <p:spPr>
-            <a:xfrm flipH="false" flipV="false" rot="0">
+            <a:xfrm>
               <a:off x="0" y="0"/>
               <a:ext cx="720034" cy="387140"/>
             </a:xfrm>
@@ -4068,9 +4114,9 @@
               <a:gdLst/>
               <a:ahLst/>
               <a:cxnLst/>
-              <a:rect r="r" b="b" t="t" l="l"/>
+              <a:rect l="l" t="t" r="r" b="b"/>
               <a:pathLst>
-                <a:path h="387140" w="720034">
+                <a:path w="720034" h="387140">
                   <a:moveTo>
                     <a:pt x="99115" y="0"/>
                   </a:moveTo>
@@ -4110,7 +4156,7 @@
                 </a:path>
               </a:pathLst>
             </a:custGeom>
-            <a:gradFill rotWithShape="true">
+            <a:gradFill rotWithShape="1">
               <a:gsLst>
                 <a:gs pos="0">
                   <a:srgbClr val="DFDFDF">
@@ -4131,11 +4177,18 @@
               <a:round/>
             </a:ln>
           </p:spPr>
+          <p:txBody>
+            <a:bodyPr/>
+            <a:lstStyle/>
+            <a:p>
+              <a:endParaRPr lang="fr-FR"/>
+            </a:p>
+          </p:txBody>
         </p:sp>
         <p:sp>
           <p:nvSpPr>
-            <p:cNvPr name="TextBox 19" id="19"/>
-            <p:cNvSpPr txBox="true"/>
+            <p:cNvPr id="19" name="TextBox 19"/>
+            <p:cNvSpPr txBox="1"/>
             <p:nvPr/>
           </p:nvSpPr>
           <p:spPr>
@@ -4148,7 +4201,7 @@
             </a:prstGeom>
           </p:spPr>
           <p:txBody>
-            <a:bodyPr anchor="ctr" rtlCol="false" tIns="50800" lIns="50800" bIns="50800" rIns="50800"/>
+            <a:bodyPr lIns="50800" tIns="50800" rIns="50800" bIns="50800" rtlCol="0" anchor="ctr"/>
             <a:lstStyle/>
             <a:p>
               <a:pPr algn="ctr">
@@ -4193,7 +4246,7 @@
       </p:grpSp>
       <p:sp>
         <p:nvSpPr>
-          <p:cNvPr name="AutoShape 20" id="20"/>
+          <p:cNvPr id="20" name="AutoShape 20"/>
           <p:cNvSpPr/>
           <p:nvPr/>
         </p:nvSpPr>
@@ -4205,24 +4258,31 @@
           <a:prstGeom prst="line">
             <a:avLst/>
           </a:prstGeom>
-          <a:ln cap="flat" w="28575">
+          <a:ln w="28575" cap="flat">
             <a:solidFill>
               <a:srgbClr val="000000"/>
             </a:solidFill>
             <a:prstDash val="sysDash"/>
-            <a:headEnd type="none" len="sm" w="sm"/>
-            <a:tailEnd type="triangle" len="med" w="lg"/>
+            <a:headEnd type="none" w="sm" len="sm"/>
+            <a:tailEnd type="triangle" w="lg" len="med"/>
           </a:ln>
         </p:spPr>
+        <p:txBody>
+          <a:bodyPr/>
+          <a:lstStyle/>
+          <a:p>
+            <a:endParaRPr lang="fr-FR"/>
+          </a:p>
+        </p:txBody>
       </p:sp>
       <p:grpSp>
         <p:nvGrpSpPr>
-          <p:cNvPr name="Group 21" id="21"/>
+          <p:cNvPr id="21" name="Group 21"/>
           <p:cNvGrpSpPr/>
           <p:nvPr/>
         </p:nvGrpSpPr>
         <p:grpSpPr>
-          <a:xfrm rot="0">
+          <a:xfrm>
             <a:off x="7777061" y="7186669"/>
             <a:ext cx="2733878" cy="1469924"/>
             <a:chOff x="0" y="0"/>
@@ -4231,12 +4291,12 @@
         </p:grpSpPr>
         <p:sp>
           <p:nvSpPr>
-            <p:cNvPr name="Freeform 22" id="22"/>
+            <p:cNvPr id="22" name="Freeform 22"/>
             <p:cNvSpPr/>
             <p:nvPr/>
           </p:nvSpPr>
           <p:spPr>
-            <a:xfrm flipH="false" flipV="false" rot="0">
+            <a:xfrm>
               <a:off x="0" y="0"/>
               <a:ext cx="720034" cy="387140"/>
             </a:xfrm>
@@ -4245,9 +4305,9 @@
               <a:gdLst/>
               <a:ahLst/>
               <a:cxnLst/>
-              <a:rect r="r" b="b" t="t" l="l"/>
+              <a:rect l="l" t="t" r="r" b="b"/>
               <a:pathLst>
-                <a:path h="387140" w="720034">
+                <a:path w="720034" h="387140">
                   <a:moveTo>
                     <a:pt x="99115" y="0"/>
                   </a:moveTo>
@@ -4287,7 +4347,7 @@
                 </a:path>
               </a:pathLst>
             </a:custGeom>
-            <a:gradFill rotWithShape="true">
+            <a:gradFill rotWithShape="1">
               <a:gsLst>
                 <a:gs pos="0">
                   <a:srgbClr val="DFDFDF">
@@ -4308,11 +4368,18 @@
               <a:round/>
             </a:ln>
           </p:spPr>
+          <p:txBody>
+            <a:bodyPr/>
+            <a:lstStyle/>
+            <a:p>
+              <a:endParaRPr lang="fr-FR"/>
+            </a:p>
+          </p:txBody>
         </p:sp>
         <p:sp>
           <p:nvSpPr>
-            <p:cNvPr name="TextBox 23" id="23"/>
-            <p:cNvSpPr txBox="true"/>
+            <p:cNvPr id="23" name="TextBox 23"/>
+            <p:cNvSpPr txBox="1"/>
             <p:nvPr/>
           </p:nvSpPr>
           <p:spPr>
@@ -4325,7 +4392,7 @@
             </a:prstGeom>
           </p:spPr>
           <p:txBody>
-            <a:bodyPr anchor="ctr" rtlCol="false" tIns="50800" lIns="50800" bIns="50800" rIns="50800"/>
+            <a:bodyPr lIns="50800" tIns="50800" rIns="50800" bIns="50800" rtlCol="0" anchor="ctr"/>
             <a:lstStyle/>
             <a:p>
               <a:pPr algn="ctr">
@@ -4334,7 +4401,7 @@
                 </a:lnSpc>
               </a:pPr>
               <a:r>
-                <a:rPr lang="en-US" sz="2400">
+                <a:rPr lang="en-US" sz="2400" dirty="0">
                   <a:solidFill>
                     <a:srgbClr val="000000"/>
                   </a:solidFill>
@@ -4353,20 +4420,7 @@
                 </a:lnSpc>
               </a:pPr>
               <a:r>
-                <a:rPr lang="en-US" sz="1900">
-                  <a:solidFill>
-                    <a:srgbClr val="000000"/>
-                  </a:solidFill>
-                  <a:latin typeface="Open Sauce"/>
-                  <a:ea typeface="Open Sauce"/>
-                  <a:cs typeface="Open Sauce"/>
-                  <a:sym typeface="Open Sauce"/>
-                  <a:hlinkClick r:id="rId2" tooltip="https://github.com/Lejeune-2025"/>
-                </a:rPr>
-                <a:t> GBAMOU </a:t>
-              </a:r>
-              <a:r>
-                <a:rPr lang="en-US" sz="1900">
+                <a:rPr lang="en-US" sz="1900" dirty="0">
                   <a:solidFill>
                     <a:srgbClr val="000000"/>
                   </a:solidFill>
@@ -4375,7 +4429,7 @@
                   <a:cs typeface="Open Sauce"/>
                   <a:sym typeface="Open Sauce"/>
                 </a:rPr>
-                <a:t>Moussa</a:t>
+                <a:t>GBAMOU Moussa</a:t>
               </a:r>
             </a:p>
           </p:txBody>
@@ -4383,36 +4437,43 @@
       </p:grpSp>
       <p:sp>
         <p:nvSpPr>
-          <p:cNvPr name="AutoShape 24" id="24"/>
+          <p:cNvPr id="24" name="AutoShape 24"/>
           <p:cNvSpPr/>
           <p:nvPr/>
         </p:nvSpPr>
         <p:spPr>
-          <a:xfrm flipH="true">
+          <a:xfrm flipH="1">
             <a:off x="9144000" y="5989412"/>
             <a:ext cx="3224645" cy="1197257"/>
           </a:xfrm>
           <a:prstGeom prst="line">
             <a:avLst/>
           </a:prstGeom>
-          <a:ln cap="flat" w="28575">
+          <a:ln w="28575" cap="flat">
             <a:solidFill>
               <a:srgbClr val="000000"/>
             </a:solidFill>
             <a:prstDash val="sysDash"/>
-            <a:headEnd type="none" len="sm" w="sm"/>
-            <a:tailEnd type="triangle" len="med" w="lg"/>
+            <a:headEnd type="none" w="sm" len="sm"/>
+            <a:tailEnd type="triangle" w="lg" len="med"/>
           </a:ln>
         </p:spPr>
-      </p:sp>
-      <p:sp>
-        <p:nvSpPr>
-          <p:cNvPr name="TextBox 25" id="25"/>
-          <p:cNvSpPr txBox="true"/>
+        <p:txBody>
+          <a:bodyPr/>
+          <a:lstStyle/>
+          <a:p>
+            <a:endParaRPr lang="fr-FR"/>
+          </a:p>
+        </p:txBody>
+      </p:sp>
+      <p:sp>
+        <p:nvSpPr>
+          <p:cNvPr id="25" name="TextBox 25"/>
+          <p:cNvSpPr txBox="1"/>
           <p:nvPr/>
         </p:nvSpPr>
         <p:spPr>
-          <a:xfrm rot="0">
+          <a:xfrm>
             <a:off x="1028700" y="5817899"/>
             <a:ext cx="4686300" cy="636270"/>
           </a:xfrm>
@@ -4421,7 +4482,7 @@
           </a:prstGeom>
         </p:spPr>
         <p:txBody>
-          <a:bodyPr anchor="t" rtlCol="false" tIns="0" lIns="0" bIns="0" rIns="0">
+          <a:bodyPr lIns="0" tIns="0" rIns="0" bIns="0" rtlCol="0" anchor="t">
             <a:spAutoFit/>
           </a:bodyPr>
           <a:lstStyle/>
@@ -4448,12 +4509,12 @@
       </p:sp>
       <p:sp>
         <p:nvSpPr>
-          <p:cNvPr name="TextBox 26" id="26"/>
-          <p:cNvSpPr txBox="true"/>
+          <p:cNvPr id="26" name="TextBox 26"/>
+          <p:cNvSpPr txBox="1"/>
           <p:nvPr/>
         </p:nvSpPr>
         <p:spPr>
-          <a:xfrm rot="0">
+          <a:xfrm>
             <a:off x="1028700" y="1057275"/>
             <a:ext cx="7342398" cy="245745"/>
           </a:xfrm>
@@ -4462,7 +4523,7 @@
           </a:prstGeom>
         </p:spPr>
         <p:txBody>
-          <a:bodyPr anchor="t" rtlCol="false" tIns="0" lIns="0" bIns="0" rIns="0">
+          <a:bodyPr lIns="0" tIns="0" rIns="0" bIns="0" rtlCol="0" anchor="t">
             <a:spAutoFit/>
           </a:bodyPr>
           <a:lstStyle/>
@@ -4476,7 +4537,7 @@
               </a:spcBef>
             </a:pPr>
             <a:r>
-              <a:rPr lang="en-US" b="true" sz="1800" spc="179">
+              <a:rPr lang="en-US" sz="1800" b="1" spc="179">
                 <a:solidFill>
                   <a:srgbClr val="8C7753"/>
                 </a:solidFill>
@@ -4492,12 +4553,12 @@
       </p:sp>
       <p:sp>
         <p:nvSpPr>
-          <p:cNvPr name="TextBox 27" id="27"/>
-          <p:cNvSpPr txBox="true"/>
+          <p:cNvPr id="27" name="TextBox 27"/>
+          <p:cNvSpPr txBox="1"/>
           <p:nvPr/>
         </p:nvSpPr>
         <p:spPr>
-          <a:xfrm rot="0">
+          <a:xfrm>
             <a:off x="1028700" y="6559555"/>
             <a:ext cx="4238166" cy="422275"/>
           </a:xfrm>
@@ -4506,7 +4567,7 @@
           </a:prstGeom>
         </p:spPr>
         <p:txBody>
-          <a:bodyPr anchor="t" rtlCol="false" tIns="0" lIns="0" bIns="0" rIns="0">
+          <a:bodyPr lIns="0" tIns="0" rIns="0" bIns="0" rtlCol="0" anchor="t">
             <a:spAutoFit/>
           </a:bodyPr>
           <a:lstStyle/>
@@ -4536,12 +4597,12 @@
       </p:sp>
       <p:sp>
         <p:nvSpPr>
-          <p:cNvPr name="TextBox 28" id="28"/>
-          <p:cNvSpPr txBox="true"/>
+          <p:cNvPr id="28" name="TextBox 28"/>
+          <p:cNvSpPr txBox="1"/>
           <p:nvPr/>
         </p:nvSpPr>
         <p:spPr>
-          <a:xfrm rot="0">
+          <a:xfrm>
             <a:off x="1028700" y="2750286"/>
             <a:ext cx="4057650" cy="789304"/>
           </a:xfrm>
@@ -4550,7 +4611,7 @@
           </a:prstGeom>
         </p:spPr>
         <p:txBody>
-          <a:bodyPr anchor="t" rtlCol="false" tIns="0" lIns="0" bIns="0" rIns="0">
+          <a:bodyPr lIns="0" tIns="0" rIns="0" bIns="0" rtlCol="0" anchor="t">
             <a:spAutoFit/>
           </a:bodyPr>
           <a:lstStyle/>
@@ -4561,7 +4622,7 @@
               </a:lnSpc>
             </a:pPr>
             <a:r>
-              <a:rPr lang="en-US" sz="2600" b="true">
+              <a:rPr lang="en-US" sz="2600" b="1">
                 <a:solidFill>
                   <a:srgbClr val="8C7753"/>
                 </a:solidFill>
@@ -4599,12 +4660,12 @@
       </p:sp>
       <p:sp>
         <p:nvSpPr>
-          <p:cNvPr name="TextBox 29" id="29"/>
-          <p:cNvSpPr txBox="true"/>
+          <p:cNvPr id="29" name="TextBox 29"/>
+          <p:cNvSpPr txBox="1"/>
           <p:nvPr/>
         </p:nvSpPr>
         <p:spPr>
-          <a:xfrm rot="0">
+          <a:xfrm>
             <a:off x="1028700" y="1910645"/>
             <a:ext cx="8115300" cy="636270"/>
           </a:xfrm>
@@ -4613,7 +4674,7 @@
           </a:prstGeom>
         </p:spPr>
         <p:txBody>
-          <a:bodyPr anchor="t" rtlCol="false" tIns="0" lIns="0" bIns="0" rIns="0">
+          <a:bodyPr lIns="0" tIns="0" rIns="0" bIns="0" rtlCol="0" anchor="t">
             <a:spAutoFit/>
           </a:bodyPr>
           <a:lstStyle/>
@@ -4640,21 +4701,21 @@
       </p:sp>
       <p:sp>
         <p:nvSpPr>
-          <p:cNvPr name="TextBox 30" id="30"/>
-          <p:cNvSpPr txBox="true"/>
+          <p:cNvPr id="30" name="TextBox 30"/>
+          <p:cNvSpPr txBox="1"/>
           <p:nvPr/>
         </p:nvSpPr>
         <p:spPr>
-          <a:xfrm rot="0">
+          <a:xfrm>
             <a:off x="1028700" y="3778048"/>
-            <a:ext cx="4057650" cy="789304"/>
+            <a:ext cx="4057650" cy="789960"/>
           </a:xfrm>
           <a:prstGeom prst="rect">
             <a:avLst/>
           </a:prstGeom>
         </p:spPr>
         <p:txBody>
-          <a:bodyPr anchor="t" rtlCol="false" tIns="0" lIns="0" bIns="0" rIns="0">
+          <a:bodyPr lIns="0" tIns="0" rIns="0" bIns="0" rtlCol="0" anchor="t">
             <a:spAutoFit/>
           </a:bodyPr>
           <a:lstStyle/>
@@ -4665,7 +4726,7 @@
               </a:lnSpc>
             </a:pPr>
             <a:r>
-              <a:rPr lang="en-US" sz="2600" b="true">
+              <a:rPr lang="en-US" sz="2600" b="1" dirty="0">
                 <a:solidFill>
                   <a:srgbClr val="8C7753"/>
                 </a:solidFill>
@@ -4687,7 +4748,7 @@
               </a:spcBef>
             </a:pPr>
             <a:r>
-              <a:rPr lang="en-US" sz="2000">
+              <a:rPr lang="en-US" sz="2000" dirty="0">
                 <a:solidFill>
                   <a:srgbClr val="8C7753"/>
                 </a:solidFill>
@@ -4696,31 +4757,19 @@
                 <a:cs typeface="Open Sauce"/>
                 <a:sym typeface="Open Sauce"/>
               </a:rPr>
-              <a:t>Plateforme de</a:t>
-            </a:r>
-            <a:r>
-              <a:rPr lang="en-US" sz="2000">
-                <a:solidFill>
-                  <a:srgbClr val="8C7753"/>
-                </a:solidFill>
-                <a:latin typeface="Open Sauce"/>
-                <a:ea typeface="Open Sauce"/>
-                <a:cs typeface="Open Sauce"/>
-                <a:sym typeface="Open Sauce"/>
-              </a:rPr>
-              <a:t> formation en ligne</a:t>
-            </a:r>
-          </a:p>
-        </p:txBody>
-      </p:sp>
-      <p:sp>
-        <p:nvSpPr>
-          <p:cNvPr name="TextBox 31" id="31"/>
-          <p:cNvSpPr txBox="true"/>
+              <a:t>Plateforme de formation en ligne</a:t>
+            </a:r>
+          </a:p>
+        </p:txBody>
+      </p:sp>
+      <p:sp>
+        <p:nvSpPr>
+          <p:cNvPr id="31" name="TextBox 31"/>
+          <p:cNvSpPr txBox="1"/>
           <p:nvPr/>
         </p:nvSpPr>
         <p:spPr>
-          <a:xfrm rot="0">
+          <a:xfrm>
             <a:off x="7039841" y="1725658"/>
             <a:ext cx="10219459" cy="636270"/>
           </a:xfrm>
@@ -4729,7 +4778,7 @@
           </a:prstGeom>
         </p:spPr>
         <p:txBody>
-          <a:bodyPr anchor="t" rtlCol="false" tIns="0" lIns="0" bIns="0" rIns="0">
+          <a:bodyPr lIns="0" tIns="0" rIns="0" bIns="0" rtlCol="0" anchor="t">
             <a:spAutoFit/>
           </a:bodyPr>
           <a:lstStyle/>
@@ -4756,12 +4805,12 @@
       </p:sp>
       <p:sp>
         <p:nvSpPr>
-          <p:cNvPr name="TextBox 32" id="32"/>
-          <p:cNvSpPr txBox="true"/>
+          <p:cNvPr id="32" name="TextBox 32"/>
+          <p:cNvSpPr txBox="1"/>
           <p:nvPr/>
         </p:nvSpPr>
         <p:spPr>
-          <a:xfrm rot="0">
+          <a:xfrm>
             <a:off x="1028700" y="7029455"/>
             <a:ext cx="4238166" cy="422275"/>
           </a:xfrm>
@@ -4770,7 +4819,7 @@
           </a:prstGeom>
         </p:spPr>
         <p:txBody>
-          <a:bodyPr anchor="t" rtlCol="false" tIns="0" lIns="0" bIns="0" rIns="0">
+          <a:bodyPr lIns="0" tIns="0" rIns="0" bIns="0" rtlCol="0" anchor="t">
             <a:spAutoFit/>
           </a:bodyPr>
           <a:lstStyle/>
@@ -4804,19 +4853,20 @@
     <a:masterClrMapping/>
   </p:clrMapOvr>
   <p:transition spd="slow">
-    <p:push dir="l"/>
+    <p:push/>
   </p:transition>
 </p:sld>
 </file>
 
 <file path=ppt/slides/slide3.xml><?xml version="1.0" encoding="utf-8"?>
-<p:sld xmlns:p="http://schemas.openxmlformats.org/presentationml/2006/main" xmlns:a="http://schemas.openxmlformats.org/drawingml/2006/main">
+<p:sld xmlns:a="http://schemas.openxmlformats.org/drawingml/2006/main" xmlns:r="http://schemas.openxmlformats.org/officeDocument/2006/relationships" xmlns:p="http://schemas.openxmlformats.org/presentationml/2006/main">
   <p:cSld>
     <p:bg>
       <p:bgPr>
         <a:solidFill>
           <a:srgbClr val="FAF7F0"/>
         </a:solidFill>
+        <a:effectLst/>
       </p:bgPr>
     </p:bg>
     <p:spTree>
@@ -4835,12 +4885,12 @@
       </p:grpSpPr>
       <p:grpSp>
         <p:nvGrpSpPr>
-          <p:cNvPr name="Group 2" id="2"/>
+          <p:cNvPr id="2" name="Group 2"/>
           <p:cNvGrpSpPr/>
           <p:nvPr/>
         </p:nvGrpSpPr>
         <p:grpSpPr>
-          <a:xfrm rot="0">
+          <a:xfrm>
             <a:off x="774542" y="1782698"/>
             <a:ext cx="4818489" cy="2102671"/>
             <a:chOff x="0" y="0"/>
@@ -4849,12 +4899,12 @@
         </p:grpSpPr>
         <p:sp>
           <p:nvSpPr>
-            <p:cNvPr name="Freeform 3" id="3"/>
+            <p:cNvPr id="3" name="Freeform 3"/>
             <p:cNvSpPr/>
             <p:nvPr/>
           </p:nvSpPr>
           <p:spPr>
-            <a:xfrm flipH="false" flipV="false" rot="0">
+            <a:xfrm>
               <a:off x="0" y="0"/>
               <a:ext cx="1269067" cy="553790"/>
             </a:xfrm>
@@ -4863,9 +4913,9 @@
               <a:gdLst/>
               <a:ahLst/>
               <a:cxnLst/>
-              <a:rect r="r" b="b" t="t" l="l"/>
+              <a:rect l="l" t="t" r="r" b="b"/>
               <a:pathLst>
-                <a:path h="553790" w="1269067">
+                <a:path w="1269067" h="553790">
                   <a:moveTo>
                     <a:pt x="44988" y="0"/>
                   </a:moveTo>
@@ -4910,7 +4960,7 @@
                 </a:path>
               </a:pathLst>
             </a:custGeom>
-            <a:gradFill rotWithShape="true">
+            <a:gradFill rotWithShape="1">
               <a:gsLst>
                 <a:gs pos="0">
                   <a:srgbClr val="000000">
@@ -4926,11 +4976,18 @@
               <a:lin ang="0"/>
             </a:gradFill>
           </p:spPr>
+          <p:txBody>
+            <a:bodyPr/>
+            <a:lstStyle/>
+            <a:p>
+              <a:endParaRPr lang="fr-FR"/>
+            </a:p>
+          </p:txBody>
         </p:sp>
         <p:sp>
           <p:nvSpPr>
-            <p:cNvPr name="TextBox 4" id="4"/>
-            <p:cNvSpPr txBox="true"/>
+            <p:cNvPr id="4" name="TextBox 4"/>
+            <p:cNvSpPr txBox="1"/>
             <p:nvPr/>
           </p:nvSpPr>
           <p:spPr>
@@ -4943,7 +5000,7 @@
             </a:prstGeom>
           </p:spPr>
           <p:txBody>
-            <a:bodyPr anchor="ctr" rtlCol="false" tIns="50800" lIns="50800" bIns="50800" rIns="50800"/>
+            <a:bodyPr lIns="50800" tIns="50800" rIns="50800" bIns="50800" rtlCol="0" anchor="ctr"/>
             <a:lstStyle/>
             <a:p>
               <a:pPr algn="ctr">
@@ -4951,32 +5008,33 @@
                   <a:spcPts val="3427"/>
                 </a:lnSpc>
               </a:pPr>
+              <a:endParaRPr/>
             </a:p>
           </p:txBody>
         </p:sp>
       </p:grpSp>
       <p:sp>
         <p:nvSpPr>
-          <p:cNvPr name="TextBox 5" id="5"/>
-          <p:cNvSpPr txBox="true"/>
+          <p:cNvPr id="5" name="TextBox 5"/>
+          <p:cNvSpPr txBox="1"/>
           <p:nvPr/>
         </p:nvSpPr>
         <p:spPr>
-          <a:xfrm rot="0">
+          <a:xfrm>
             <a:off x="1028700" y="5086350"/>
-            <a:ext cx="4310172" cy="2511171"/>
+            <a:ext cx="4310172" cy="2566344"/>
           </a:xfrm>
           <a:prstGeom prst="rect">
             <a:avLst/>
           </a:prstGeom>
         </p:spPr>
         <p:txBody>
-          <a:bodyPr anchor="t" rtlCol="false" tIns="0" lIns="0" bIns="0" rIns="0">
+          <a:bodyPr lIns="0" tIns="0" rIns="0" bIns="0" rtlCol="0" anchor="t">
             <a:spAutoFit/>
           </a:bodyPr>
           <a:lstStyle/>
           <a:p>
-            <a:pPr algn="l" marL="410211" indent="-205106" lvl="1">
+            <a:pPr marL="410211" lvl="1" indent="-205106" algn="l">
               <a:lnSpc>
                 <a:spcPts val="2907"/>
               </a:lnSpc>
@@ -4984,7 +5042,7 @@
               <a:buChar char="•"/>
             </a:pPr>
             <a:r>
-              <a:rPr lang="en-US" sz="1900">
+              <a:rPr lang="en-US" sz="1900" dirty="0">
                 <a:solidFill>
                   <a:srgbClr val="331B0D"/>
                 </a:solidFill>
@@ -4997,7 +5055,7 @@
             </a:r>
           </a:p>
           <a:p>
-            <a:pPr algn="l" marL="410211" indent="-205106" lvl="1">
+            <a:pPr marL="410211" lvl="1" indent="-205106" algn="l">
               <a:lnSpc>
                 <a:spcPts val="2907"/>
               </a:lnSpc>
@@ -5005,7 +5063,7 @@
               <a:buChar char="•"/>
             </a:pPr>
             <a:r>
-              <a:rPr lang="en-US" sz="1900">
+              <a:rPr lang="en-US" sz="1900" dirty="0">
                 <a:solidFill>
                   <a:srgbClr val="331B0D"/>
                 </a:solidFill>
@@ -5018,7 +5076,7 @@
             </a:r>
           </a:p>
           <a:p>
-            <a:pPr algn="l" marL="410211" indent="-205106" lvl="1">
+            <a:pPr marL="410211" lvl="1" indent="-205106" algn="l">
               <a:lnSpc>
                 <a:spcPts val="2907"/>
               </a:lnSpc>
@@ -5026,7 +5084,7 @@
               <a:buChar char="•"/>
             </a:pPr>
             <a:r>
-              <a:rPr lang="en-US" sz="1900">
+              <a:rPr lang="en-US" sz="1900" dirty="0">
                 <a:solidFill>
                   <a:srgbClr val="331B0D"/>
                 </a:solidFill>
@@ -5035,7 +5093,7 @@
                 <a:cs typeface="Open Sauce"/>
                 <a:sym typeface="Open Sauce"/>
               </a:rPr>
-              <a:t>Correction de bugs bloquants et réorganisation du code.</a:t>
+              <a:t>Correction de bugs bloquants et réorganisation du code</a:t>
             </a:r>
           </a:p>
           <a:p>
@@ -5044,17 +5102,26 @@
                 <a:spcPts val="2907"/>
               </a:lnSpc>
             </a:pPr>
-          </a:p>
-        </p:txBody>
-      </p:sp>
-      <p:sp>
-        <p:nvSpPr>
-          <p:cNvPr name="TextBox 6" id="6"/>
-          <p:cNvSpPr txBox="true"/>
+            <a:endParaRPr lang="en-US" sz="1900" dirty="0">
+              <a:solidFill>
+                <a:srgbClr val="331B0D"/>
+              </a:solidFill>
+              <a:latin typeface="Open Sauce"/>
+              <a:ea typeface="Open Sauce"/>
+              <a:cs typeface="Open Sauce"/>
+              <a:sym typeface="Open Sauce"/>
+            </a:endParaRPr>
+          </a:p>
+        </p:txBody>
+      </p:sp>
+      <p:sp>
+        <p:nvSpPr>
+          <p:cNvPr id="6" name="TextBox 6"/>
+          <p:cNvSpPr txBox="1"/>
           <p:nvPr/>
         </p:nvSpPr>
         <p:spPr>
-          <a:xfrm rot="0">
+          <a:xfrm>
             <a:off x="1028700" y="1057275"/>
             <a:ext cx="2847786" cy="245745"/>
           </a:xfrm>
@@ -5063,7 +5130,7 @@
           </a:prstGeom>
         </p:spPr>
         <p:txBody>
-          <a:bodyPr anchor="t" rtlCol="false" tIns="0" lIns="0" bIns="0" rIns="0">
+          <a:bodyPr lIns="0" tIns="0" rIns="0" bIns="0" rtlCol="0" anchor="t">
             <a:spAutoFit/>
           </a:bodyPr>
           <a:lstStyle/>
@@ -5077,7 +5144,7 @@
               </a:spcBef>
             </a:pPr>
             <a:r>
-              <a:rPr lang="en-US" b="true" sz="1800" spc="179">
+              <a:rPr lang="en-US" sz="1800" b="1" spc="179">
                 <a:solidFill>
                   <a:srgbClr val="8C7753"/>
                 </a:solidFill>
@@ -5093,21 +5160,21 @@
       </p:sp>
       <p:sp>
         <p:nvSpPr>
-          <p:cNvPr name="TextBox 7" id="7"/>
-          <p:cNvSpPr txBox="true"/>
+          <p:cNvPr id="7" name="TextBox 7"/>
+          <p:cNvSpPr txBox="1"/>
           <p:nvPr/>
         </p:nvSpPr>
         <p:spPr>
-          <a:xfrm rot="0">
+          <a:xfrm>
             <a:off x="1067666" y="4422198"/>
-            <a:ext cx="4310172" cy="457836"/>
+            <a:ext cx="4310172" cy="436017"/>
           </a:xfrm>
           <a:prstGeom prst="rect">
             <a:avLst/>
           </a:prstGeom>
         </p:spPr>
         <p:txBody>
-          <a:bodyPr anchor="t" rtlCol="false" tIns="0" lIns="0" bIns="0" rIns="0">
+          <a:bodyPr lIns="0" tIns="0" rIns="0" bIns="0" rtlCol="0" anchor="t">
             <a:spAutoFit/>
           </a:bodyPr>
           <a:lstStyle/>
@@ -5118,7 +5185,7 @@
               </a:lnSpc>
             </a:pPr>
             <a:r>
-              <a:rPr lang="en-US" sz="3400" spc="-204">
+              <a:rPr lang="en-US" sz="3400" spc="-204" dirty="0">
                 <a:solidFill>
                   <a:srgbClr val="331B0D"/>
                 </a:solidFill>
@@ -5127,19 +5194,19 @@
                 <a:cs typeface="Open Sauce"/>
                 <a:sym typeface="Open Sauce"/>
               </a:rPr>
-              <a:t>Objectifs</a:t>
-            </a:r>
-          </a:p>
-        </p:txBody>
-      </p:sp>
-      <p:sp>
-        <p:nvSpPr>
-          <p:cNvPr name="TextBox 8" id="8"/>
-          <p:cNvSpPr txBox="true"/>
+              <a:t>Objectifs du projet</a:t>
+            </a:r>
+          </a:p>
+        </p:txBody>
+      </p:sp>
+      <p:sp>
+        <p:nvSpPr>
+          <p:cNvPr id="8" name="TextBox 8"/>
+          <p:cNvSpPr txBox="1"/>
           <p:nvPr/>
         </p:nvSpPr>
         <p:spPr>
-          <a:xfrm rot="0">
+          <a:xfrm>
             <a:off x="1067666" y="2070576"/>
             <a:ext cx="4310172" cy="457836"/>
           </a:xfrm>
@@ -5148,7 +5215,7 @@
           </a:prstGeom>
         </p:spPr>
         <p:txBody>
-          <a:bodyPr anchor="t" rtlCol="false" tIns="0" lIns="0" bIns="0" rIns="0">
+          <a:bodyPr lIns="0" tIns="0" rIns="0" bIns="0" rtlCol="0" anchor="t">
             <a:spAutoFit/>
           </a:bodyPr>
           <a:lstStyle/>
@@ -5175,12 +5242,12 @@
       </p:sp>
       <p:sp>
         <p:nvSpPr>
-          <p:cNvPr name="TextBox 9" id="9"/>
-          <p:cNvSpPr txBox="true"/>
+          <p:cNvPr id="9" name="TextBox 9"/>
+          <p:cNvSpPr txBox="1"/>
           <p:nvPr/>
         </p:nvSpPr>
         <p:spPr>
-          <a:xfrm rot="0">
+          <a:xfrm>
             <a:off x="1067666" y="2600291"/>
             <a:ext cx="4310172" cy="1063371"/>
           </a:xfrm>
@@ -5189,7 +5256,7 @@
           </a:prstGeom>
         </p:spPr>
         <p:txBody>
-          <a:bodyPr anchor="t" rtlCol="false" tIns="0" lIns="0" bIns="0" rIns="0">
+          <a:bodyPr lIns="0" tIns="0" rIns="0" bIns="0" rtlCol="0" anchor="t">
             <a:spAutoFit/>
           </a:bodyPr>
           <a:lstStyle/>
@@ -5209,32 +5276,20 @@
                 <a:cs typeface="Open Sauce"/>
                 <a:sym typeface="Open Sauce"/>
               </a:rPr>
-              <a:t>S</a:t>
-            </a:r>
-            <a:r>
-              <a:rPr lang="en-US" sz="1900">
-                <a:solidFill>
-                  <a:srgbClr val="8C7753"/>
-                </a:solidFill>
-                <a:latin typeface="Open Sauce"/>
-                <a:ea typeface="Open Sauce"/>
-                <a:cs typeface="Open Sauce"/>
-                <a:sym typeface="Open Sauce"/>
-              </a:rPr>
-              <a:t>ite web destiné à la formation hotelière et digitale &amp; business pour la Guinée.</a:t>
-            </a:r>
-          </a:p>
-        </p:txBody>
-      </p:sp>
-      <p:sp>
-        <p:nvSpPr>
-          <p:cNvPr name="TextBox 10" id="10"/>
-          <p:cNvSpPr txBox="true"/>
+              <a:t>Site web destiné à la formation hotelière et digitale &amp; business pour la Guinée.</a:t>
+            </a:r>
+          </a:p>
+        </p:txBody>
+      </p:sp>
+      <p:sp>
+        <p:nvSpPr>
+          <p:cNvPr id="10" name="TextBox 10"/>
+          <p:cNvSpPr txBox="1"/>
           <p:nvPr/>
         </p:nvSpPr>
         <p:spPr>
-          <a:xfrm rot="0">
-            <a:off x="6930465" y="4148465"/>
+          <a:xfrm>
+            <a:off x="9753600" y="3427533"/>
             <a:ext cx="2621107" cy="457836"/>
           </a:xfrm>
           <a:prstGeom prst="rect">
@@ -5242,7 +5297,7 @@
           </a:prstGeom>
         </p:spPr>
         <p:txBody>
-          <a:bodyPr anchor="t" rtlCol="false" tIns="0" lIns="0" bIns="0" rIns="0">
+          <a:bodyPr lIns="0" tIns="0" rIns="0" bIns="0" rtlCol="0" anchor="t">
             <a:spAutoFit/>
           </a:bodyPr>
           <a:lstStyle/>
@@ -5269,26 +5324,26 @@
       </p:sp>
       <p:sp>
         <p:nvSpPr>
-          <p:cNvPr name="TextBox 11" id="11"/>
-          <p:cNvSpPr txBox="true"/>
+          <p:cNvPr id="11" name="TextBox 11"/>
+          <p:cNvSpPr txBox="1"/>
           <p:nvPr/>
         </p:nvSpPr>
         <p:spPr>
-          <a:xfrm rot="0">
-            <a:off x="6930465" y="4638365"/>
-            <a:ext cx="4427070" cy="1425321"/>
+          <a:xfrm>
+            <a:off x="9753600" y="3917433"/>
+            <a:ext cx="4427070" cy="1822550"/>
           </a:xfrm>
           <a:prstGeom prst="rect">
             <a:avLst/>
           </a:prstGeom>
         </p:spPr>
         <p:txBody>
-          <a:bodyPr anchor="t" rtlCol="false" tIns="0" lIns="0" bIns="0" rIns="0">
+          <a:bodyPr lIns="0" tIns="0" rIns="0" bIns="0" rtlCol="0" anchor="t">
             <a:spAutoFit/>
           </a:bodyPr>
           <a:lstStyle/>
           <a:p>
-            <a:pPr algn="l" marL="410211" indent="-205106" lvl="1">
+            <a:pPr marL="410211" lvl="1" indent="-205106" algn="l">
               <a:lnSpc>
                 <a:spcPts val="2907"/>
               </a:lnSpc>
@@ -5296,7 +5351,7 @@
               <a:buChar char="•"/>
             </a:pPr>
             <a:r>
-              <a:rPr lang="en-US" sz="1900">
+              <a:rPr lang="en-US" sz="1900" dirty="0">
                 <a:solidFill>
                   <a:srgbClr val="331B0D"/>
                 </a:solidFill>
@@ -5305,11 +5360,11 @@
                 <a:cs typeface="Open Sauce"/>
                 <a:sym typeface="Open Sauce"/>
               </a:rPr>
-              <a:t>Migration de l'intégralité du code CSS  vers Tailwind CSS.</a:t>
-            </a:r>
-          </a:p>
-          <a:p>
-            <a:pPr algn="l" marL="410211" indent="-205106" lvl="1">
+              <a:t>Migration de l'intégralité du code CSS vers Tailwind CSS</a:t>
+            </a:r>
+          </a:p>
+          <a:p>
+            <a:pPr marL="410211" lvl="1" indent="-205106">
               <a:lnSpc>
                 <a:spcPts val="2907"/>
               </a:lnSpc>
@@ -5317,7 +5372,7 @@
               <a:buChar char="•"/>
             </a:pPr>
             <a:r>
-              <a:rPr lang="en-US" sz="1900">
+              <a:rPr lang="en-US" sz="1900" dirty="0">
                 <a:solidFill>
                   <a:srgbClr val="331B0D"/>
                 </a:solidFill>
@@ -5326,7 +5381,28 @@
                 <a:cs typeface="Open Sauce"/>
                 <a:sym typeface="Open Sauce"/>
               </a:rPr>
-              <a:t>Création des pages structurelles. </a:t>
+              <a:t>Création des pages structurelles </a:t>
+            </a:r>
+          </a:p>
+          <a:p>
+            <a:pPr marL="410211" lvl="1" indent="-205106" algn="l">
+              <a:lnSpc>
+                <a:spcPts val="2907"/>
+              </a:lnSpc>
+              <a:buFont typeface="Arial"/>
+              <a:buChar char="•"/>
+            </a:pPr>
+            <a:r>
+              <a:rPr lang="en-US" sz="1900" dirty="0">
+                <a:solidFill>
+                  <a:srgbClr val="331B0D"/>
+                </a:solidFill>
+                <a:latin typeface="Open Sauce"/>
+                <a:ea typeface="Open Sauce"/>
+                <a:cs typeface="Open Sauce"/>
+                <a:sym typeface="Open Sauce"/>
+              </a:rPr>
+              <a:t>Modification du style visuel</a:t>
             </a:r>
           </a:p>
           <a:p>
@@ -5335,32 +5411,41 @@
                 <a:spcPts val="2907"/>
               </a:lnSpc>
             </a:pPr>
+            <a:endParaRPr lang="en-US" sz="1900" dirty="0">
+              <a:solidFill>
+                <a:srgbClr val="331B0D"/>
+              </a:solidFill>
+              <a:latin typeface="Open Sauce"/>
+              <a:ea typeface="Open Sauce"/>
+              <a:cs typeface="Open Sauce"/>
+              <a:sym typeface="Open Sauce"/>
+            </a:endParaRPr>
           </a:p>
         </p:txBody>
       </p:sp>
       <p:grpSp>
         <p:nvGrpSpPr>
-          <p:cNvPr name="Group 12" id="12"/>
+          <p:cNvPr id="12" name="Group 12"/>
           <p:cNvGrpSpPr/>
           <p:nvPr/>
         </p:nvGrpSpPr>
         <p:grpSpPr>
-          <a:xfrm rot="0">
-            <a:off x="774542" y="4135617"/>
-            <a:ext cx="4818489" cy="3856137"/>
-            <a:chOff x="0" y="0"/>
-            <a:chExt cx="1269067" cy="1015608"/>
+          <a:xfrm>
+            <a:off x="774542" y="4066780"/>
+            <a:ext cx="5968655" cy="4087151"/>
+            <a:chOff x="1204240" y="170066"/>
+            <a:chExt cx="1567656" cy="1076451"/>
           </a:xfrm>
         </p:grpSpPr>
         <p:sp>
           <p:nvSpPr>
-            <p:cNvPr name="Freeform 13" id="13"/>
+            <p:cNvPr id="13" name="Freeform 13"/>
             <p:cNvSpPr/>
             <p:nvPr/>
           </p:nvSpPr>
           <p:spPr>
-            <a:xfrm flipH="false" flipV="false" rot="0">
-              <a:off x="0" y="0"/>
+            <a:xfrm>
+              <a:off x="1204240" y="170066"/>
               <a:ext cx="1269067" cy="1015608"/>
             </a:xfrm>
             <a:custGeom>
@@ -5368,9 +5453,9 @@
               <a:gdLst/>
               <a:ahLst/>
               <a:cxnLst/>
-              <a:rect r="r" b="b" t="t" l="l"/>
+              <a:rect l="l" t="t" r="r" b="b"/>
               <a:pathLst>
-                <a:path h="1015608" w="1269067">
+                <a:path w="1269067" h="1015608">
                   <a:moveTo>
                     <a:pt x="44988" y="0"/>
                   </a:moveTo>
@@ -5415,7 +5500,7 @@
                 </a:path>
               </a:pathLst>
             </a:custGeom>
-            <a:gradFill rotWithShape="true">
+            <a:gradFill rotWithShape="1">
               <a:gsLst>
                 <a:gs pos="0">
                   <a:srgbClr val="000000">
@@ -5431,16 +5516,23 @@
               <a:lin ang="0"/>
             </a:gradFill>
           </p:spPr>
+          <p:txBody>
+            <a:bodyPr/>
+            <a:lstStyle/>
+            <a:p>
+              <a:endParaRPr lang="fr-FR" dirty="0"/>
+            </a:p>
+          </p:txBody>
         </p:sp>
         <p:sp>
           <p:nvSpPr>
-            <p:cNvPr name="TextBox 14" id="14"/>
-            <p:cNvSpPr txBox="true"/>
+            <p:cNvPr id="14" name="TextBox 14"/>
+            <p:cNvSpPr txBox="1"/>
             <p:nvPr/>
           </p:nvSpPr>
           <p:spPr>
             <a:xfrm>
-              <a:off x="0" y="-47625"/>
+              <a:off x="1502829" y="183284"/>
               <a:ext cx="1269067" cy="1063233"/>
             </a:xfrm>
             <a:prstGeom prst="rect">
@@ -5448,7 +5540,7 @@
             </a:prstGeom>
           </p:spPr>
           <p:txBody>
-            <a:bodyPr anchor="ctr" rtlCol="false" tIns="50800" lIns="50800" bIns="50800" rIns="50800"/>
+            <a:bodyPr lIns="50800" tIns="50800" rIns="50800" bIns="50800" rtlCol="0" anchor="ctr"/>
             <a:lstStyle/>
             <a:p>
               <a:pPr algn="ctr">
@@ -5456,32 +5548,33 @@
                   <a:spcPts val="3427"/>
                 </a:lnSpc>
               </a:pPr>
+              <a:endParaRPr/>
             </a:p>
           </p:txBody>
         </p:sp>
       </p:grpSp>
       <p:grpSp>
         <p:nvGrpSpPr>
-          <p:cNvPr name="Group 15" id="15"/>
+          <p:cNvPr id="15" name="Group 15"/>
           <p:cNvGrpSpPr/>
           <p:nvPr/>
         </p:nvGrpSpPr>
         <p:grpSpPr>
-          <a:xfrm rot="0">
-            <a:off x="6734756" y="3885370"/>
-            <a:ext cx="4818489" cy="2102671"/>
+          <a:xfrm>
+            <a:off x="9549449" y="3142314"/>
+            <a:ext cx="4818489" cy="2560507"/>
             <a:chOff x="0" y="0"/>
             <a:chExt cx="1269067" cy="553790"/>
           </a:xfrm>
         </p:grpSpPr>
         <p:sp>
           <p:nvSpPr>
-            <p:cNvPr name="Freeform 16" id="16"/>
+            <p:cNvPr id="16" name="Freeform 16"/>
             <p:cNvSpPr/>
             <p:nvPr/>
           </p:nvSpPr>
           <p:spPr>
-            <a:xfrm flipH="false" flipV="false" rot="0">
+            <a:xfrm>
               <a:off x="0" y="0"/>
               <a:ext cx="1269067" cy="553790"/>
             </a:xfrm>
@@ -5490,9 +5583,9 @@
               <a:gdLst/>
               <a:ahLst/>
               <a:cxnLst/>
-              <a:rect r="r" b="b" t="t" l="l"/>
+              <a:rect l="l" t="t" r="r" b="b"/>
               <a:pathLst>
-                <a:path h="553790" w="1269067">
+                <a:path w="1269067" h="553790">
                   <a:moveTo>
                     <a:pt x="44988" y="0"/>
                   </a:moveTo>
@@ -5537,7 +5630,7 @@
                 </a:path>
               </a:pathLst>
             </a:custGeom>
-            <a:gradFill rotWithShape="true">
+            <a:gradFill rotWithShape="1">
               <a:gsLst>
                 <a:gs pos="0">
                   <a:srgbClr val="000000">
@@ -5553,11 +5646,18 @@
               <a:lin ang="0"/>
             </a:gradFill>
           </p:spPr>
+          <p:txBody>
+            <a:bodyPr/>
+            <a:lstStyle/>
+            <a:p>
+              <a:endParaRPr lang="fr-FR" dirty="0"/>
+            </a:p>
+          </p:txBody>
         </p:sp>
         <p:sp>
           <p:nvSpPr>
-            <p:cNvPr name="TextBox 17" id="17"/>
-            <p:cNvSpPr txBox="true"/>
+            <p:cNvPr id="17" name="TextBox 17"/>
+            <p:cNvSpPr txBox="1"/>
             <p:nvPr/>
           </p:nvSpPr>
           <p:spPr>
@@ -5570,7 +5670,7 @@
             </a:prstGeom>
           </p:spPr>
           <p:txBody>
-            <a:bodyPr anchor="ctr" rtlCol="false" tIns="50800" lIns="50800" bIns="50800" rIns="50800"/>
+            <a:bodyPr lIns="50800" tIns="50800" rIns="50800" bIns="50800" rtlCol="0" anchor="ctr"/>
             <a:lstStyle/>
             <a:p>
               <a:pPr algn="ctr">
@@ -5578,117 +5678,588 @@
                   <a:spcPts val="3427"/>
                 </a:lnSpc>
               </a:pPr>
+              <a:endParaRPr/>
             </a:p>
           </p:txBody>
         </p:sp>
       </p:grpSp>
-      <p:sp>
-        <p:nvSpPr>
-          <p:cNvPr name="TextBox 18" id="18"/>
-          <p:cNvSpPr txBox="true"/>
+    </p:spTree>
+  </p:cSld>
+  <p:clrMapOvr>
+    <a:masterClrMapping/>
+  </p:clrMapOvr>
+  <p:transition spd="slow">
+    <p:push/>
+  </p:transition>
+</p:sld>
+</file>
+
+<file path=ppt/slides/slide4.xml><?xml version="1.0" encoding="utf-8"?>
+<p:sld xmlns:a="http://schemas.openxmlformats.org/drawingml/2006/main" xmlns:r="http://schemas.openxmlformats.org/officeDocument/2006/relationships" xmlns:p="http://schemas.openxmlformats.org/presentationml/2006/main">
+  <p:cSld>
+    <p:bg>
+      <p:bgPr>
+        <a:solidFill>
+          <a:srgbClr val="FAF7F0"/>
+        </a:solidFill>
+        <a:effectLst/>
+      </p:bgPr>
+    </p:bg>
+    <p:spTree>
+      <p:nvGrpSpPr>
+        <p:cNvPr id="1" name=""/>
+        <p:cNvGrpSpPr/>
+        <p:nvPr/>
+      </p:nvGrpSpPr>
+      <p:grpSpPr>
+        <a:xfrm>
+          <a:off x="0" y="0"/>
+          <a:ext cx="0" cy="0"/>
+          <a:chOff x="0" y="0"/>
+          <a:chExt cx="0" cy="0"/>
+        </a:xfrm>
+      </p:grpSpPr>
+      <p:sp>
+        <p:nvSpPr>
+          <p:cNvPr id="2" name="Freeform 2"/>
+          <p:cNvSpPr/>
           <p:nvPr/>
         </p:nvSpPr>
         <p:spPr>
-          <a:xfrm rot="0">
-            <a:off x="12766985" y="2042641"/>
-            <a:ext cx="8115300" cy="457836"/>
+          <a:xfrm>
+            <a:off x="1295400" y="1862267"/>
+            <a:ext cx="8382000" cy="4352548"/>
+          </a:xfrm>
+          <a:custGeom>
+            <a:avLst/>
+            <a:gdLst/>
+            <a:ahLst/>
+            <a:cxnLst/>
+            <a:rect l="l" t="t" r="r" b="b"/>
+            <a:pathLst>
+              <a:path w="10115542" h="5714881">
+                <a:moveTo>
+                  <a:pt x="0" y="0"/>
+                </a:moveTo>
+                <a:lnTo>
+                  <a:pt x="10115542" y="0"/>
+                </a:lnTo>
+                <a:lnTo>
+                  <a:pt x="10115542" y="5714882"/>
+                </a:lnTo>
+                <a:lnTo>
+                  <a:pt x="0" y="5714882"/>
+                </a:lnTo>
+                <a:lnTo>
+                  <a:pt x="0" y="0"/>
+                </a:lnTo>
+                <a:close/>
+              </a:path>
+            </a:pathLst>
+          </a:custGeom>
+          <a:blipFill>
+            <a:blip r:embed="rId2"/>
+            <a:stretch>
+              <a:fillRect l="-3942" r="-4184"/>
+            </a:stretch>
+          </a:blipFill>
+        </p:spPr>
+        <p:txBody>
+          <a:bodyPr/>
+          <a:lstStyle/>
+          <a:p>
+            <a:endParaRPr lang="fr-FR"/>
+          </a:p>
+        </p:txBody>
+      </p:sp>
+      <p:sp>
+        <p:nvSpPr>
+          <p:cNvPr id="3" name="TextBox 3"/>
+          <p:cNvSpPr txBox="1"/>
+          <p:nvPr/>
+        </p:nvSpPr>
+        <p:spPr>
+          <a:xfrm>
+            <a:off x="1028700" y="933450"/>
+            <a:ext cx="4056898" cy="459105"/>
           </a:xfrm>
           <a:prstGeom prst="rect">
             <a:avLst/>
           </a:prstGeom>
         </p:spPr>
         <p:txBody>
-          <a:bodyPr anchor="t" rtlCol="false" tIns="0" lIns="0" bIns="0" rIns="0">
+          <a:bodyPr lIns="0" tIns="0" rIns="0" bIns="0" rtlCol="0" anchor="t">
             <a:spAutoFit/>
           </a:bodyPr>
           <a:lstStyle/>
           <a:p>
             <a:pPr algn="l">
               <a:lnSpc>
-                <a:spcPts val="3400"/>
+                <a:spcPts val="3840"/>
               </a:lnSpc>
             </a:pPr>
             <a:r>
-              <a:rPr lang="en-US" sz="3400" spc="-204">
+              <a:rPr lang="en-US" sz="2400">
                 <a:solidFill>
-                  <a:srgbClr val="331B0D"/>
+                  <a:srgbClr val="8C7753"/>
                 </a:solidFill>
                 <a:latin typeface="Open Sauce"/>
                 <a:ea typeface="Open Sauce"/>
                 <a:cs typeface="Open Sauce"/>
                 <a:sym typeface="Open Sauce"/>
               </a:rPr>
-              <a:t>Collaboration</a:t>
-            </a:r>
-          </a:p>
-        </p:txBody>
-      </p:sp>
-      <p:sp>
-        <p:nvSpPr>
-          <p:cNvPr name="TextBox 19" id="19"/>
-          <p:cNvSpPr txBox="true"/>
+              <a:t>CAPTURE D’ECRAN</a:t>
+            </a:r>
+          </a:p>
+        </p:txBody>
+      </p:sp>
+      <p:sp>
+        <p:nvSpPr>
+          <p:cNvPr id="4" name="TextBox 4"/>
+          <p:cNvSpPr txBox="1"/>
           <p:nvPr/>
         </p:nvSpPr>
         <p:spPr>
-          <a:xfrm rot="0">
-            <a:off x="12766985" y="2529052"/>
-            <a:ext cx="4427070" cy="1063371"/>
+          <a:xfrm>
+            <a:off x="11531891" y="2072487"/>
+            <a:ext cx="2613242" cy="415948"/>
           </a:xfrm>
           <a:prstGeom prst="rect">
             <a:avLst/>
           </a:prstGeom>
         </p:spPr>
         <p:txBody>
-          <a:bodyPr anchor="t" rtlCol="false" tIns="0" lIns="0" bIns="0" rIns="0">
+          <a:bodyPr lIns="0" tIns="0" rIns="0" bIns="0" rtlCol="0" anchor="t">
             <a:spAutoFit/>
           </a:bodyPr>
           <a:lstStyle/>
           <a:p>
-            <a:pPr algn="l" marL="410211" indent="-205106" lvl="1">
+            <a:pPr algn="just">
               <a:lnSpc>
-                <a:spcPts val="2907"/>
+                <a:spcPts val="3427"/>
               </a:lnSpc>
-              <a:buFont typeface="Arial"/>
-              <a:buChar char="•"/>
+              <a:spcBef>
+                <a:spcPct val="0"/>
+              </a:spcBef>
             </a:pPr>
             <a:r>
-              <a:rPr lang="en-US" sz="1900">
+              <a:rPr lang="en-US" sz="2448" dirty="0">
                 <a:solidFill>
-                  <a:srgbClr val="331B0D"/>
+                  <a:srgbClr val="8C7753"/>
                 </a:solidFill>
                 <a:latin typeface="Open Sauce"/>
                 <a:ea typeface="Open Sauce"/>
                 <a:cs typeface="Open Sauce"/>
                 <a:sym typeface="Open Sauce"/>
               </a:rPr>
-              <a:t>Travail d’équipe en appel sur Discord (partage d'écran/pair programming).</a:t>
-            </a:r>
+              <a:t>Langages utilisés</a:t>
+            </a:r>
+          </a:p>
+        </p:txBody>
+      </p:sp>
+      <p:sp>
+        <p:nvSpPr>
+          <p:cNvPr id="5" name="TextBox 5"/>
+          <p:cNvSpPr txBox="1"/>
+          <p:nvPr/>
+        </p:nvSpPr>
+        <p:spPr>
+          <a:xfrm>
+            <a:off x="11531891" y="2599859"/>
+            <a:ext cx="3022309" cy="2137979"/>
+          </a:xfrm>
+          <a:prstGeom prst="rect">
+            <a:avLst/>
+          </a:prstGeom>
+        </p:spPr>
+        <p:txBody>
+          <a:bodyPr wrap="square" lIns="0" tIns="0" rIns="0" bIns="0" rtlCol="0" anchor="t">
+            <a:spAutoFit/>
+          </a:bodyPr>
+          <a:lstStyle/>
+          <a:p>
+            <a:pPr marL="528572" lvl="1" indent="-264286" algn="just">
+              <a:lnSpc>
+                <a:spcPts val="3427"/>
+              </a:lnSpc>
+              <a:buFont typeface="Arial"/>
+              <a:buChar char="•"/>
+            </a:pPr>
+            <a:r>
+              <a:rPr lang="en-US" sz="2448" dirty="0">
+                <a:solidFill>
+                  <a:srgbClr val="000000"/>
+                </a:solidFill>
+                <a:latin typeface="Open Sauce"/>
+                <a:ea typeface="Open Sauce"/>
+                <a:cs typeface="Open Sauce"/>
+                <a:sym typeface="Open Sauce"/>
+              </a:rPr>
+              <a:t>React</a:t>
+            </a:r>
+          </a:p>
+          <a:p>
+            <a:pPr marL="528572" lvl="1" indent="-264286" algn="just">
+              <a:lnSpc>
+                <a:spcPts val="3427"/>
+              </a:lnSpc>
+              <a:buFont typeface="Arial"/>
+              <a:buChar char="•"/>
+            </a:pPr>
+            <a:r>
+              <a:rPr lang="en-US" sz="2448" dirty="0">
+                <a:solidFill>
+                  <a:srgbClr val="000000"/>
+                </a:solidFill>
+                <a:latin typeface="Open Sauce"/>
+                <a:ea typeface="Open Sauce"/>
+                <a:cs typeface="Open Sauce"/>
+                <a:sym typeface="Open Sauce"/>
+              </a:rPr>
+              <a:t>Next JS</a:t>
+            </a:r>
+          </a:p>
+          <a:p>
+            <a:pPr marL="528572" lvl="1" indent="-264286" algn="just">
+              <a:lnSpc>
+                <a:spcPts val="3427"/>
+              </a:lnSpc>
+              <a:buFont typeface="Arial"/>
+              <a:buChar char="•"/>
+            </a:pPr>
+            <a:r>
+              <a:rPr lang="en-US" sz="2448" dirty="0">
+                <a:solidFill>
+                  <a:srgbClr val="000000"/>
+                </a:solidFill>
+                <a:latin typeface="Open Sauce"/>
+                <a:ea typeface="Open Sauce"/>
+                <a:cs typeface="Open Sauce"/>
+                <a:sym typeface="Open Sauce"/>
+              </a:rPr>
+              <a:t>Tailwind CSS</a:t>
+            </a:r>
+          </a:p>
+          <a:p>
+            <a:pPr marL="528572" lvl="1" indent="-264286" algn="just">
+              <a:lnSpc>
+                <a:spcPts val="3427"/>
+              </a:lnSpc>
+              <a:buFont typeface="Arial"/>
+              <a:buChar char="•"/>
+            </a:pPr>
+            <a:r>
+              <a:rPr lang="en-US" sz="2448" dirty="0">
+                <a:solidFill>
+                  <a:srgbClr val="000000"/>
+                </a:solidFill>
+                <a:latin typeface="Open Sauce"/>
+                <a:ea typeface="Open Sauce"/>
+                <a:cs typeface="Open Sauce"/>
+                <a:sym typeface="Open Sauce"/>
+              </a:rPr>
+              <a:t>Lucid icons</a:t>
+            </a:r>
+          </a:p>
+          <a:p>
+            <a:pPr marL="528572" lvl="1" indent="-264286" algn="just">
+              <a:lnSpc>
+                <a:spcPts val="3427"/>
+              </a:lnSpc>
+              <a:spcBef>
+                <a:spcPct val="0"/>
+              </a:spcBef>
+              <a:buFont typeface="Arial"/>
+              <a:buChar char="•"/>
+            </a:pPr>
+            <a:r>
+              <a:rPr lang="en-US" sz="2448" dirty="0">
+                <a:solidFill>
+                  <a:srgbClr val="000000"/>
+                </a:solidFill>
+                <a:latin typeface="Open Sauce"/>
+                <a:ea typeface="Open Sauce"/>
+                <a:cs typeface="Open Sauce"/>
+                <a:sym typeface="Open Sauce"/>
+              </a:rPr>
+              <a:t>GSAP</a:t>
+            </a:r>
+          </a:p>
+        </p:txBody>
+      </p:sp>
+      <p:sp>
+        <p:nvSpPr>
+          <p:cNvPr id="6" name="TextBox 6"/>
+          <p:cNvSpPr txBox="1"/>
+          <p:nvPr/>
+        </p:nvSpPr>
+        <p:spPr>
+          <a:xfrm>
+            <a:off x="11531891" y="5067300"/>
+            <a:ext cx="2574228" cy="415948"/>
+          </a:xfrm>
+          <a:prstGeom prst="rect">
+            <a:avLst/>
+          </a:prstGeom>
+        </p:spPr>
+        <p:txBody>
+          <a:bodyPr lIns="0" tIns="0" rIns="0" bIns="0" rtlCol="0" anchor="t">
+            <a:spAutoFit/>
+          </a:bodyPr>
+          <a:lstStyle/>
+          <a:p>
+            <a:pPr algn="ctr">
+              <a:lnSpc>
+                <a:spcPts val="3427"/>
+              </a:lnSpc>
+              <a:spcBef>
+                <a:spcPct val="0"/>
+              </a:spcBef>
+            </a:pPr>
+            <a:r>
+              <a:rPr lang="en-US" sz="2448" dirty="0">
+                <a:solidFill>
+                  <a:srgbClr val="8C7753"/>
+                </a:solidFill>
+                <a:latin typeface="Open Sauce"/>
+                <a:ea typeface="Open Sauce"/>
+                <a:cs typeface="Open Sauce"/>
+                <a:sym typeface="Open Sauce"/>
+              </a:rPr>
+              <a:t>Logiciels utilisés </a:t>
+            </a:r>
+          </a:p>
+        </p:txBody>
+      </p:sp>
+      <p:sp>
+        <p:nvSpPr>
+          <p:cNvPr id="7" name="TextBox 7"/>
+          <p:cNvSpPr txBox="1"/>
+          <p:nvPr/>
+        </p:nvSpPr>
+        <p:spPr>
+          <a:xfrm>
+            <a:off x="11531891" y="5499577"/>
+            <a:ext cx="2184109" cy="1276964"/>
+          </a:xfrm>
+          <a:prstGeom prst="rect">
+            <a:avLst/>
+          </a:prstGeom>
+        </p:spPr>
+        <p:txBody>
+          <a:bodyPr wrap="square" lIns="0" tIns="0" rIns="0" bIns="0" rtlCol="0" anchor="t">
+            <a:spAutoFit/>
+          </a:bodyPr>
+          <a:lstStyle/>
+          <a:p>
+            <a:pPr marL="528572" lvl="1" indent="-264286" algn="l">
+              <a:lnSpc>
+                <a:spcPts val="3427"/>
+              </a:lnSpc>
+              <a:buFont typeface="Arial"/>
+              <a:buChar char="•"/>
+            </a:pPr>
+            <a:r>
+              <a:rPr lang="en-US" sz="2448" dirty="0">
+                <a:solidFill>
+                  <a:srgbClr val="000000"/>
+                </a:solidFill>
+                <a:latin typeface="Open Sauce"/>
+                <a:ea typeface="Open Sauce"/>
+                <a:cs typeface="Open Sauce"/>
+                <a:sym typeface="Open Sauce"/>
+              </a:rPr>
+              <a:t>VS CODE</a:t>
+            </a:r>
+          </a:p>
+          <a:p>
+            <a:pPr marL="528572" lvl="1" indent="-264286" algn="l">
+              <a:lnSpc>
+                <a:spcPts val="3427"/>
+              </a:lnSpc>
+              <a:buFont typeface="Arial"/>
+              <a:buChar char="•"/>
+            </a:pPr>
+            <a:r>
+              <a:rPr lang="en-US" sz="2448" dirty="0">
+                <a:solidFill>
+                  <a:srgbClr val="000000"/>
+                </a:solidFill>
+                <a:latin typeface="Open Sauce"/>
+                <a:ea typeface="Open Sauce"/>
+                <a:cs typeface="Open Sauce"/>
+                <a:sym typeface="Open Sauce"/>
+              </a:rPr>
+              <a:t>Trello</a:t>
+            </a:r>
+          </a:p>
+          <a:p>
+            <a:pPr marL="528572" lvl="1" indent="-264286" algn="l">
+              <a:lnSpc>
+                <a:spcPts val="3427"/>
+              </a:lnSpc>
+              <a:spcBef>
+                <a:spcPct val="0"/>
+              </a:spcBef>
+              <a:buFont typeface="Arial"/>
+              <a:buChar char="•"/>
+            </a:pPr>
+            <a:r>
+              <a:rPr lang="en-US" sz="2448" dirty="0">
+                <a:solidFill>
+                  <a:srgbClr val="000000"/>
+                </a:solidFill>
+                <a:latin typeface="Open Sauce"/>
+                <a:ea typeface="Open Sauce"/>
+                <a:cs typeface="Open Sauce"/>
+                <a:sym typeface="Open Sauce"/>
+              </a:rPr>
+              <a:t>Github</a:t>
+            </a:r>
+          </a:p>
+        </p:txBody>
+      </p:sp>
+      <p:sp>
+        <p:nvSpPr>
+          <p:cNvPr id="8" name="TextBox 8"/>
+          <p:cNvSpPr txBox="1"/>
+          <p:nvPr/>
+        </p:nvSpPr>
+        <p:spPr>
+          <a:xfrm>
+            <a:off x="11614162" y="7152345"/>
+            <a:ext cx="4064413" cy="415948"/>
+          </a:xfrm>
+          <a:prstGeom prst="rect">
+            <a:avLst/>
+          </a:prstGeom>
+        </p:spPr>
+        <p:txBody>
+          <a:bodyPr lIns="0" tIns="0" rIns="0" bIns="0" rtlCol="0" anchor="t">
+            <a:spAutoFit/>
+          </a:bodyPr>
+          <a:lstStyle/>
+          <a:p>
+            <a:pPr algn="just">
+              <a:lnSpc>
+                <a:spcPts val="3427"/>
+              </a:lnSpc>
+              <a:spcBef>
+                <a:spcPct val="0"/>
+              </a:spcBef>
+            </a:pPr>
+            <a:r>
+              <a:rPr lang="en-US" sz="2448" dirty="0">
+                <a:solidFill>
+                  <a:srgbClr val="8C7753"/>
+                </a:solidFill>
+                <a:latin typeface="Open Sauce"/>
+                <a:ea typeface="Open Sauce"/>
+                <a:cs typeface="Open Sauce"/>
+                <a:sym typeface="Open Sauce"/>
+              </a:rPr>
+              <a:t>Moyens de communication</a:t>
+            </a:r>
+          </a:p>
+        </p:txBody>
+      </p:sp>
+      <p:sp>
+        <p:nvSpPr>
+          <p:cNvPr id="9" name="TextBox 9"/>
+          <p:cNvSpPr txBox="1"/>
+          <p:nvPr/>
+        </p:nvSpPr>
+        <p:spPr>
+          <a:xfrm>
+            <a:off x="11614162" y="7584622"/>
+            <a:ext cx="2101838" cy="846456"/>
+          </a:xfrm>
+          <a:prstGeom prst="rect">
+            <a:avLst/>
+          </a:prstGeom>
+        </p:spPr>
+        <p:txBody>
+          <a:bodyPr wrap="square" lIns="0" tIns="0" rIns="0" bIns="0" rtlCol="0" anchor="t">
+            <a:spAutoFit/>
+          </a:bodyPr>
+          <a:lstStyle/>
+          <a:p>
+            <a:pPr marL="528572" lvl="1" indent="-264286" algn="just">
+              <a:lnSpc>
+                <a:spcPts val="3427"/>
+              </a:lnSpc>
+              <a:buFont typeface="Arial"/>
+              <a:buChar char="•"/>
+            </a:pPr>
+            <a:r>
+              <a:rPr lang="en-US" sz="2448" dirty="0">
+                <a:solidFill>
+                  <a:srgbClr val="000000"/>
+                </a:solidFill>
+                <a:latin typeface="Open Sauce"/>
+                <a:ea typeface="Open Sauce"/>
+                <a:cs typeface="Open Sauce"/>
+                <a:sym typeface="Open Sauce"/>
+              </a:rPr>
+              <a:t>Discord</a:t>
+            </a:r>
+          </a:p>
+          <a:p>
+            <a:pPr algn="just">
+              <a:lnSpc>
+                <a:spcPts val="3427"/>
+              </a:lnSpc>
+              <a:spcBef>
+                <a:spcPct val="0"/>
+              </a:spcBef>
+            </a:pPr>
+            <a:endParaRPr lang="en-US" sz="2448" dirty="0">
+              <a:solidFill>
+                <a:srgbClr val="000000"/>
+              </a:solidFill>
+              <a:latin typeface="Open Sauce"/>
+              <a:ea typeface="Open Sauce"/>
+              <a:cs typeface="Open Sauce"/>
+              <a:sym typeface="Open Sauce"/>
+            </a:endParaRPr>
           </a:p>
         </p:txBody>
       </p:sp>
       <p:grpSp>
         <p:nvGrpSpPr>
-          <p:cNvPr name="Group 20" id="20"/>
+          <p:cNvPr id="10" name="Group 20">
+            <a:extLst>
+              <a:ext uri="{FF2B5EF4-FFF2-40B4-BE49-F238E27FC236}">
+                <a16:creationId xmlns:a16="http://schemas.microsoft.com/office/drawing/2014/main" id="{075F1326-F417-E820-8A6B-BF41BCE777E9}"/>
+              </a:ext>
+            </a:extLst>
+          </p:cNvPr>
           <p:cNvGrpSpPr/>
           <p:nvPr/>
         </p:nvGrpSpPr>
         <p:grpSpPr>
-          <a:xfrm rot="0">
-            <a:off x="12571275" y="1782698"/>
-            <a:ext cx="4818489" cy="2102671"/>
-            <a:chOff x="0" y="0"/>
-            <a:chExt cx="1269067" cy="553790"/>
+          <a:xfrm>
+            <a:off x="1028700" y="4791383"/>
+            <a:ext cx="4851146" cy="4087829"/>
+            <a:chOff x="0" y="-47625"/>
+            <a:chExt cx="1277668" cy="1076630"/>
           </a:xfrm>
         </p:grpSpPr>
         <p:sp>
           <p:nvSpPr>
-            <p:cNvPr name="Freeform 21" id="21"/>
+            <p:cNvPr id="11" name="Freeform 21">
+              <a:extLst>
+                <a:ext uri="{FF2B5EF4-FFF2-40B4-BE49-F238E27FC236}">
+                  <a16:creationId xmlns:a16="http://schemas.microsoft.com/office/drawing/2014/main" id="{9EE21AAE-4ECE-2D30-E070-3B6C5DEDC541}"/>
+                </a:ext>
+              </a:extLst>
+            </p:cNvPr>
             <p:cNvSpPr/>
             <p:nvPr/>
           </p:nvSpPr>
           <p:spPr>
-            <a:xfrm flipH="false" flipV="false" rot="0">
-              <a:off x="0" y="0"/>
+            <a:xfrm>
+              <a:off x="8601" y="475215"/>
               <a:ext cx="1269067" cy="553790"/>
             </a:xfrm>
             <a:custGeom>
@@ -5696,9 +6267,9 @@
               <a:gdLst/>
               <a:ahLst/>
               <a:cxnLst/>
-              <a:rect r="r" b="b" t="t" l="l"/>
+              <a:rect l="l" t="t" r="r" b="b"/>
               <a:pathLst>
-                <a:path h="553790" w="1269067">
+                <a:path w="1269067" h="553790">
                   <a:moveTo>
                     <a:pt x="44988" y="0"/>
                   </a:moveTo>
@@ -5743,7 +6314,7 @@
                 </a:path>
               </a:pathLst>
             </a:custGeom>
-            <a:gradFill rotWithShape="true">
+            <a:gradFill rotWithShape="1">
               <a:gsLst>
                 <a:gs pos="0">
                   <a:srgbClr val="000000">
@@ -5759,11 +6330,24 @@
               <a:lin ang="0"/>
             </a:gradFill>
           </p:spPr>
+          <p:txBody>
+            <a:bodyPr/>
+            <a:lstStyle/>
+            <a:p>
+              <a:endParaRPr lang="fr-FR" dirty="0"/>
+            </a:p>
+          </p:txBody>
         </p:sp>
         <p:sp>
           <p:nvSpPr>
-            <p:cNvPr name="TextBox 22" id="22"/>
-            <p:cNvSpPr txBox="true"/>
+            <p:cNvPr id="12" name="TextBox 22">
+              <a:extLst>
+                <a:ext uri="{FF2B5EF4-FFF2-40B4-BE49-F238E27FC236}">
+                  <a16:creationId xmlns:a16="http://schemas.microsoft.com/office/drawing/2014/main" id="{BED12A31-970F-3BDD-2E59-5E3032BFB1ED}"/>
+                </a:ext>
+              </a:extLst>
+            </p:cNvPr>
+            <p:cNvSpPr txBox="1"/>
             <p:nvPr/>
           </p:nvSpPr>
           <p:spPr>
@@ -5776,7 +6360,7 @@
             </a:prstGeom>
           </p:spPr>
           <p:txBody>
-            <a:bodyPr anchor="ctr" rtlCol="false" tIns="50800" lIns="50800" bIns="50800" rIns="50800"/>
+            <a:bodyPr lIns="50800" tIns="50800" rIns="50800" bIns="50800" rtlCol="0" anchor="ctr"/>
             <a:lstStyle/>
             <a:p>
               <a:pPr algn="ctr">
@@ -5784,103 +6368,26 @@
                   <a:spcPts val="3427"/>
                 </a:lnSpc>
               </a:pPr>
+              <a:endParaRPr/>
             </a:p>
           </p:txBody>
         </p:sp>
       </p:grpSp>
-      <p:sp>
-        <p:nvSpPr>
-          <p:cNvPr name="TextBox 23" id="23"/>
-          <p:cNvSpPr txBox="true"/>
-          <p:nvPr/>
-        </p:nvSpPr>
-        <p:spPr>
-          <a:xfrm rot="0">
-            <a:off x="12766985" y="6149026"/>
-            <a:ext cx="8115300" cy="457836"/>
-          </a:xfrm>
-          <a:prstGeom prst="rect">
-            <a:avLst/>
-          </a:prstGeom>
-        </p:spPr>
-        <p:txBody>
-          <a:bodyPr anchor="t" rtlCol="false" tIns="0" lIns="0" bIns="0" rIns="0">
-            <a:spAutoFit/>
-          </a:bodyPr>
-          <a:lstStyle/>
-          <a:p>
-            <a:pPr algn="l">
-              <a:lnSpc>
-                <a:spcPts val="3400"/>
-              </a:lnSpc>
-            </a:pPr>
-            <a:r>
-              <a:rPr lang="en-US" sz="3400" spc="-204">
-                <a:solidFill>
-                  <a:srgbClr val="331B0D"/>
-                </a:solidFill>
-                <a:latin typeface="Open Sauce"/>
-                <a:ea typeface="Open Sauce"/>
-                <a:cs typeface="Open Sauce"/>
-                <a:sym typeface="Open Sauce"/>
-              </a:rPr>
-              <a:t>Suivi</a:t>
-            </a:r>
-          </a:p>
-        </p:txBody>
-      </p:sp>
-      <p:sp>
-        <p:nvSpPr>
-          <p:cNvPr name="TextBox 24" id="24"/>
-          <p:cNvSpPr txBox="true"/>
-          <p:nvPr/>
-        </p:nvSpPr>
-        <p:spPr>
-          <a:xfrm rot="0">
-            <a:off x="12766985" y="6635437"/>
-            <a:ext cx="4427070" cy="701421"/>
-          </a:xfrm>
-          <a:prstGeom prst="rect">
-            <a:avLst/>
-          </a:prstGeom>
-        </p:spPr>
-        <p:txBody>
-          <a:bodyPr anchor="t" rtlCol="false" tIns="0" lIns="0" bIns="0" rIns="0">
-            <a:spAutoFit/>
-          </a:bodyPr>
-          <a:lstStyle/>
-          <a:p>
-            <a:pPr algn="l" marL="410211" indent="-205106" lvl="1">
-              <a:lnSpc>
-                <a:spcPts val="2907"/>
-              </a:lnSpc>
-              <a:buFont typeface="Arial"/>
-              <a:buChar char="•"/>
-            </a:pPr>
-            <a:r>
-              <a:rPr lang="en-US" sz="1900">
-                <a:solidFill>
-                  <a:srgbClr val="331B0D"/>
-                </a:solidFill>
-                <a:latin typeface="Open Sauce"/>
-                <a:ea typeface="Open Sauce"/>
-                <a:cs typeface="Open Sauce"/>
-                <a:sym typeface="Open Sauce"/>
-              </a:rPr>
-              <a:t>Reporting des avancées et feedback tuteur tous les 3 jours.</a:t>
-            </a:r>
-          </a:p>
-        </p:txBody>
-      </p:sp>
       <p:grpSp>
         <p:nvGrpSpPr>
-          <p:cNvPr name="Group 25" id="25"/>
+          <p:cNvPr id="13" name="Group 25">
+            <a:extLst>
+              <a:ext uri="{FF2B5EF4-FFF2-40B4-BE49-F238E27FC236}">
+                <a16:creationId xmlns:a16="http://schemas.microsoft.com/office/drawing/2014/main" id="{67BD2C0D-9D16-5A9C-F55C-27987A58AE49}"/>
+              </a:ext>
+            </a:extLst>
+          </p:cNvPr>
           <p:cNvGrpSpPr/>
           <p:nvPr/>
         </p:nvGrpSpPr>
         <p:grpSpPr>
-          <a:xfrm rot="0">
-            <a:off x="12571275" y="5889083"/>
+          <a:xfrm>
+            <a:off x="6243190" y="6776541"/>
             <a:ext cx="4818489" cy="2102671"/>
             <a:chOff x="0" y="0"/>
             <a:chExt cx="1269067" cy="553790"/>
@@ -5888,12 +6395,18 @@
         </p:grpSpPr>
         <p:sp>
           <p:nvSpPr>
-            <p:cNvPr name="Freeform 26" id="26"/>
+            <p:cNvPr id="14" name="Freeform 26">
+              <a:extLst>
+                <a:ext uri="{FF2B5EF4-FFF2-40B4-BE49-F238E27FC236}">
+                  <a16:creationId xmlns:a16="http://schemas.microsoft.com/office/drawing/2014/main" id="{8753BADF-7BFF-7734-3E3C-EDE366138AFC}"/>
+                </a:ext>
+              </a:extLst>
+            </p:cNvPr>
             <p:cNvSpPr/>
             <p:nvPr/>
           </p:nvSpPr>
           <p:spPr>
-            <a:xfrm flipH="false" flipV="false" rot="0">
+            <a:xfrm>
               <a:off x="0" y="0"/>
               <a:ext cx="1269067" cy="553790"/>
             </a:xfrm>
@@ -5902,9 +6415,9 @@
               <a:gdLst/>
               <a:ahLst/>
               <a:cxnLst/>
-              <a:rect r="r" b="b" t="t" l="l"/>
+              <a:rect l="l" t="t" r="r" b="b"/>
               <a:pathLst>
-                <a:path h="553790" w="1269067">
+                <a:path w="1269067" h="553790">
                   <a:moveTo>
                     <a:pt x="44988" y="0"/>
                   </a:moveTo>
@@ -5949,7 +6462,7 @@
                 </a:path>
               </a:pathLst>
             </a:custGeom>
-            <a:gradFill rotWithShape="true">
+            <a:gradFill rotWithShape="1">
               <a:gsLst>
                 <a:gs pos="0">
                   <a:srgbClr val="000000">
@@ -5965,11 +6478,24 @@
               <a:lin ang="0"/>
             </a:gradFill>
           </p:spPr>
+          <p:txBody>
+            <a:bodyPr/>
+            <a:lstStyle/>
+            <a:p>
+              <a:endParaRPr lang="fr-FR" dirty="0"/>
+            </a:p>
+          </p:txBody>
         </p:sp>
         <p:sp>
           <p:nvSpPr>
-            <p:cNvPr name="TextBox 27" id="27"/>
-            <p:cNvSpPr txBox="true"/>
+            <p:cNvPr id="15" name="TextBox 27">
+              <a:extLst>
+                <a:ext uri="{FF2B5EF4-FFF2-40B4-BE49-F238E27FC236}">
+                  <a16:creationId xmlns:a16="http://schemas.microsoft.com/office/drawing/2014/main" id="{17F2ADBB-175B-6512-E340-BC9F3F332325}"/>
+                </a:ext>
+              </a:extLst>
+            </p:cNvPr>
+            <p:cNvSpPr txBox="1"/>
             <p:nvPr/>
           </p:nvSpPr>
           <p:spPr>
@@ -5982,7 +6508,7 @@
             </a:prstGeom>
           </p:spPr>
           <p:txBody>
-            <a:bodyPr anchor="ctr" rtlCol="false" tIns="50800" lIns="50800" bIns="50800" rIns="50800"/>
+            <a:bodyPr lIns="50800" tIns="50800" rIns="50800" bIns="50800" rtlCol="0" anchor="ctr"/>
             <a:lstStyle/>
             <a:p>
               <a:pPr algn="ctr">
@@ -5990,29 +6516,223 @@
                   <a:spcPts val="3427"/>
                 </a:lnSpc>
               </a:pPr>
+              <a:endParaRPr/>
             </a:p>
           </p:txBody>
         </p:sp>
       </p:grpSp>
+      <p:sp>
+        <p:nvSpPr>
+          <p:cNvPr id="19" name="TextBox 18">
+            <a:extLst>
+              <a:ext uri="{FF2B5EF4-FFF2-40B4-BE49-F238E27FC236}">
+                <a16:creationId xmlns:a16="http://schemas.microsoft.com/office/drawing/2014/main" id="{BAA0CC5E-295C-57CF-10D9-810A960777E2}"/>
+              </a:ext>
+            </a:extLst>
+          </p:cNvPr>
+          <p:cNvSpPr txBox="1"/>
+          <p:nvPr/>
+        </p:nvSpPr>
+        <p:spPr>
+          <a:xfrm>
+            <a:off x="1420119" y="7026583"/>
+            <a:ext cx="8115300" cy="457836"/>
+          </a:xfrm>
+          <a:prstGeom prst="rect">
+            <a:avLst/>
+          </a:prstGeom>
+        </p:spPr>
+        <p:txBody>
+          <a:bodyPr lIns="0" tIns="0" rIns="0" bIns="0" rtlCol="0" anchor="t">
+            <a:spAutoFit/>
+          </a:bodyPr>
+          <a:lstStyle/>
+          <a:p>
+            <a:pPr algn="l">
+              <a:lnSpc>
+                <a:spcPts val="3400"/>
+              </a:lnSpc>
+            </a:pPr>
+            <a:r>
+              <a:rPr lang="en-US" sz="3400" spc="-204">
+                <a:solidFill>
+                  <a:srgbClr val="331B0D"/>
+                </a:solidFill>
+                <a:latin typeface="Open Sauce"/>
+                <a:ea typeface="Open Sauce"/>
+                <a:cs typeface="Open Sauce"/>
+                <a:sym typeface="Open Sauce"/>
+              </a:rPr>
+              <a:t>Collaboration</a:t>
+            </a:r>
+          </a:p>
+        </p:txBody>
+      </p:sp>
+      <p:sp>
+        <p:nvSpPr>
+          <p:cNvPr id="20" name="TextBox 19">
+            <a:extLst>
+              <a:ext uri="{FF2B5EF4-FFF2-40B4-BE49-F238E27FC236}">
+                <a16:creationId xmlns:a16="http://schemas.microsoft.com/office/drawing/2014/main" id="{AF4DC92C-51DD-5C4A-937F-49D2A89D3B48}"/>
+              </a:ext>
+            </a:extLst>
+          </p:cNvPr>
+          <p:cNvSpPr txBox="1"/>
+          <p:nvPr/>
+        </p:nvSpPr>
+        <p:spPr>
+          <a:xfrm>
+            <a:off x="1420119" y="7512994"/>
+            <a:ext cx="4427070" cy="1078757"/>
+          </a:xfrm>
+          <a:prstGeom prst="rect">
+            <a:avLst/>
+          </a:prstGeom>
+        </p:spPr>
+        <p:txBody>
+          <a:bodyPr lIns="0" tIns="0" rIns="0" bIns="0" rtlCol="0" anchor="t">
+            <a:spAutoFit/>
+          </a:bodyPr>
+          <a:lstStyle/>
+          <a:p>
+            <a:pPr marL="410211" lvl="1" indent="-205106" algn="l">
+              <a:lnSpc>
+                <a:spcPts val="2907"/>
+              </a:lnSpc>
+              <a:buFont typeface="Arial"/>
+              <a:buChar char="•"/>
+            </a:pPr>
+            <a:r>
+              <a:rPr lang="en-US" sz="1900" dirty="0">
+                <a:solidFill>
+                  <a:srgbClr val="331B0D"/>
+                </a:solidFill>
+                <a:latin typeface="Open Sauce"/>
+                <a:ea typeface="Open Sauce"/>
+                <a:cs typeface="Open Sauce"/>
+                <a:sym typeface="Open Sauce"/>
+              </a:rPr>
+              <a:t>Travail d’équipe en appel sur Discord (partage d'écran/pair programming)</a:t>
+            </a:r>
+          </a:p>
+        </p:txBody>
+      </p:sp>
+      <p:sp>
+        <p:nvSpPr>
+          <p:cNvPr id="21" name="TextBox 23">
+            <a:extLst>
+              <a:ext uri="{FF2B5EF4-FFF2-40B4-BE49-F238E27FC236}">
+                <a16:creationId xmlns:a16="http://schemas.microsoft.com/office/drawing/2014/main" id="{04CD4AA0-FE55-4C55-552C-3844D31A460C}"/>
+              </a:ext>
+            </a:extLst>
+          </p:cNvPr>
+          <p:cNvSpPr txBox="1"/>
+          <p:nvPr/>
+        </p:nvSpPr>
+        <p:spPr>
+          <a:xfrm>
+            <a:off x="6438900" y="7074880"/>
+            <a:ext cx="8115300" cy="457836"/>
+          </a:xfrm>
+          <a:prstGeom prst="rect">
+            <a:avLst/>
+          </a:prstGeom>
+        </p:spPr>
+        <p:txBody>
+          <a:bodyPr lIns="0" tIns="0" rIns="0" bIns="0" rtlCol="0" anchor="t">
+            <a:spAutoFit/>
+          </a:bodyPr>
+          <a:lstStyle/>
+          <a:p>
+            <a:pPr algn="l">
+              <a:lnSpc>
+                <a:spcPts val="3400"/>
+              </a:lnSpc>
+            </a:pPr>
+            <a:r>
+              <a:rPr lang="en-US" sz="3400" spc="-204">
+                <a:solidFill>
+                  <a:srgbClr val="331B0D"/>
+                </a:solidFill>
+                <a:latin typeface="Open Sauce"/>
+                <a:ea typeface="Open Sauce"/>
+                <a:cs typeface="Open Sauce"/>
+                <a:sym typeface="Open Sauce"/>
+              </a:rPr>
+              <a:t>Suivi</a:t>
+            </a:r>
+          </a:p>
+        </p:txBody>
+      </p:sp>
+      <p:sp>
+        <p:nvSpPr>
+          <p:cNvPr id="22" name="TextBox 24">
+            <a:extLst>
+              <a:ext uri="{FF2B5EF4-FFF2-40B4-BE49-F238E27FC236}">
+                <a16:creationId xmlns:a16="http://schemas.microsoft.com/office/drawing/2014/main" id="{E53EC54D-1EF9-0FAD-907F-A048C7B0EEC3}"/>
+              </a:ext>
+            </a:extLst>
+          </p:cNvPr>
+          <p:cNvSpPr txBox="1"/>
+          <p:nvPr/>
+        </p:nvSpPr>
+        <p:spPr>
+          <a:xfrm>
+            <a:off x="6438900" y="7561291"/>
+            <a:ext cx="4427070" cy="701421"/>
+          </a:xfrm>
+          <a:prstGeom prst="rect">
+            <a:avLst/>
+          </a:prstGeom>
+        </p:spPr>
+        <p:txBody>
+          <a:bodyPr lIns="0" tIns="0" rIns="0" bIns="0" rtlCol="0" anchor="t">
+            <a:spAutoFit/>
+          </a:bodyPr>
+          <a:lstStyle/>
+          <a:p>
+            <a:pPr marL="410211" lvl="1" indent="-205106" algn="l">
+              <a:lnSpc>
+                <a:spcPts val="2907"/>
+              </a:lnSpc>
+              <a:buFont typeface="Arial"/>
+              <a:buChar char="•"/>
+            </a:pPr>
+            <a:r>
+              <a:rPr lang="en-US" sz="1900" dirty="0">
+                <a:solidFill>
+                  <a:srgbClr val="331B0D"/>
+                </a:solidFill>
+                <a:latin typeface="Open Sauce"/>
+                <a:ea typeface="Open Sauce"/>
+                <a:cs typeface="Open Sauce"/>
+                <a:sym typeface="Open Sauce"/>
+              </a:rPr>
+              <a:t>Reporting des avancées au tuteur tous les 3 jours</a:t>
+            </a:r>
+          </a:p>
+        </p:txBody>
+      </p:sp>
     </p:spTree>
   </p:cSld>
   <p:clrMapOvr>
     <a:masterClrMapping/>
   </p:clrMapOvr>
   <p:transition spd="slow">
-    <p:push dir="l"/>
+    <p:push/>
   </p:transition>
 </p:sld>
 </file>
 
-<file path=ppt/slides/slide4.xml><?xml version="1.0" encoding="utf-8"?>
-<p:sld xmlns:p="http://schemas.openxmlformats.org/presentationml/2006/main" xmlns:a="http://schemas.openxmlformats.org/drawingml/2006/main" xmlns:r="http://schemas.openxmlformats.org/officeDocument/2006/relationships">
+<file path=ppt/slides/slide5.xml><?xml version="1.0" encoding="utf-8"?>
+<p:sld xmlns:a="http://schemas.openxmlformats.org/drawingml/2006/main" xmlns:r="http://schemas.openxmlformats.org/officeDocument/2006/relationships" xmlns:p="http://schemas.openxmlformats.org/presentationml/2006/main">
   <p:cSld>
     <p:bg>
       <p:bgPr>
         <a:solidFill>
           <a:srgbClr val="FAF7F0"/>
         </a:solidFill>
+        <a:effectLst/>
       </p:bgPr>
     </p:bg>
     <p:spTree>
@@ -6031,558 +6751,21 @@
       </p:grpSpPr>
       <p:sp>
         <p:nvSpPr>
-          <p:cNvPr name="Freeform 2" id="2"/>
-          <p:cNvSpPr/>
+          <p:cNvPr id="2" name="TextBox 2"/>
+          <p:cNvSpPr txBox="1"/>
           <p:nvPr/>
         </p:nvSpPr>
         <p:spPr>
-          <a:xfrm flipH="false" flipV="false" rot="0">
-            <a:off x="1028700" y="2382513"/>
-            <a:ext cx="10115542" cy="5714881"/>
-          </a:xfrm>
-          <a:custGeom>
-            <a:avLst/>
-            <a:gdLst/>
-            <a:ahLst/>
-            <a:cxnLst/>
-            <a:rect r="r" b="b" t="t" l="l"/>
-            <a:pathLst>
-              <a:path h="5714881" w="10115542">
-                <a:moveTo>
-                  <a:pt x="0" y="0"/>
-                </a:moveTo>
-                <a:lnTo>
-                  <a:pt x="10115542" y="0"/>
-                </a:lnTo>
-                <a:lnTo>
-                  <a:pt x="10115542" y="5714882"/>
-                </a:lnTo>
-                <a:lnTo>
-                  <a:pt x="0" y="5714882"/>
-                </a:lnTo>
-                <a:lnTo>
-                  <a:pt x="0" y="0"/>
-                </a:lnTo>
-                <a:close/>
-              </a:path>
-            </a:pathLst>
-          </a:custGeom>
-          <a:blipFill>
-            <a:blip r:embed="rId2"/>
-            <a:stretch>
-              <a:fillRect l="-3942" t="0" r="-4184" b="0"/>
-            </a:stretch>
-          </a:blipFill>
-        </p:spPr>
-      </p:sp>
-      <p:sp>
-        <p:nvSpPr>
-          <p:cNvPr name="TextBox 3" id="3"/>
-          <p:cNvSpPr txBox="true"/>
-          <p:nvPr/>
-        </p:nvSpPr>
-        <p:spPr>
-          <a:xfrm rot="0">
-            <a:off x="1028700" y="933450"/>
-            <a:ext cx="4056898" cy="459105"/>
+          <a:xfrm>
+            <a:off x="933450" y="2696608"/>
+            <a:ext cx="10910528" cy="1735035"/>
           </a:xfrm>
           <a:prstGeom prst="rect">
             <a:avLst/>
           </a:prstGeom>
         </p:spPr>
         <p:txBody>
-          <a:bodyPr anchor="t" rtlCol="false" tIns="0" lIns="0" bIns="0" rIns="0">
-            <a:spAutoFit/>
-          </a:bodyPr>
-          <a:lstStyle/>
-          <a:p>
-            <a:pPr algn="l">
-              <a:lnSpc>
-                <a:spcPts val="3840"/>
-              </a:lnSpc>
-            </a:pPr>
-            <a:r>
-              <a:rPr lang="en-US" sz="2400">
-                <a:solidFill>
-                  <a:srgbClr val="8C7753"/>
-                </a:solidFill>
-                <a:latin typeface="Open Sauce"/>
-                <a:ea typeface="Open Sauce"/>
-                <a:cs typeface="Open Sauce"/>
-                <a:sym typeface="Open Sauce"/>
-              </a:rPr>
-              <a:t>CAPTURE D’ECRAN</a:t>
-            </a:r>
-          </a:p>
-        </p:txBody>
-      </p:sp>
-      <p:sp>
-        <p:nvSpPr>
-          <p:cNvPr name="TextBox 4" id="4"/>
-          <p:cNvSpPr txBox="true"/>
-          <p:nvPr/>
-        </p:nvSpPr>
-        <p:spPr>
-          <a:xfrm rot="0">
-            <a:off x="11531891" y="2072487"/>
-            <a:ext cx="2613242" cy="415948"/>
-          </a:xfrm>
-          <a:prstGeom prst="rect">
-            <a:avLst/>
-          </a:prstGeom>
-        </p:spPr>
-        <p:txBody>
-          <a:bodyPr anchor="t" rtlCol="false" tIns="0" lIns="0" bIns="0" rIns="0">
-            <a:spAutoFit/>
-          </a:bodyPr>
-          <a:lstStyle/>
-          <a:p>
-            <a:pPr algn="just">
-              <a:lnSpc>
-                <a:spcPts val="3427"/>
-              </a:lnSpc>
-              <a:spcBef>
-                <a:spcPct val="0"/>
-              </a:spcBef>
-            </a:pPr>
-            <a:r>
-              <a:rPr lang="en-US" sz="2448">
-                <a:solidFill>
-                  <a:srgbClr val="8C7753"/>
-                </a:solidFill>
-                <a:latin typeface="Open Sauce"/>
-                <a:ea typeface="Open Sauce"/>
-                <a:cs typeface="Open Sauce"/>
-                <a:sym typeface="Open Sauce"/>
-              </a:rPr>
-              <a:t>Langages utilisés</a:t>
-            </a:r>
-          </a:p>
-        </p:txBody>
-      </p:sp>
-      <p:sp>
-        <p:nvSpPr>
-          <p:cNvPr name="TextBox 5" id="5"/>
-          <p:cNvSpPr txBox="true"/>
-          <p:nvPr/>
-        </p:nvSpPr>
-        <p:spPr>
-          <a:xfrm rot="0">
-            <a:off x="11531891" y="2599859"/>
-            <a:ext cx="2451951" cy="2137979"/>
-          </a:xfrm>
-          <a:prstGeom prst="rect">
-            <a:avLst/>
-          </a:prstGeom>
-        </p:spPr>
-        <p:txBody>
-          <a:bodyPr anchor="t" rtlCol="false" tIns="0" lIns="0" bIns="0" rIns="0">
-            <a:spAutoFit/>
-          </a:bodyPr>
-          <a:lstStyle/>
-          <a:p>
-            <a:pPr algn="just" marL="528572" indent="-264286" lvl="1">
-              <a:lnSpc>
-                <a:spcPts val="3427"/>
-              </a:lnSpc>
-              <a:buFont typeface="Arial"/>
-              <a:buChar char="•"/>
-            </a:pPr>
-            <a:r>
-              <a:rPr lang="en-US" sz="2448">
-                <a:solidFill>
-                  <a:srgbClr val="000000"/>
-                </a:solidFill>
-                <a:latin typeface="Open Sauce"/>
-                <a:ea typeface="Open Sauce"/>
-                <a:cs typeface="Open Sauce"/>
-                <a:sym typeface="Open Sauce"/>
-              </a:rPr>
-              <a:t>React</a:t>
-            </a:r>
-          </a:p>
-          <a:p>
-            <a:pPr algn="just" marL="528572" indent="-264286" lvl="1">
-              <a:lnSpc>
-                <a:spcPts val="3427"/>
-              </a:lnSpc>
-              <a:buFont typeface="Arial"/>
-              <a:buChar char="•"/>
-            </a:pPr>
-            <a:r>
-              <a:rPr lang="en-US" sz="2448">
-                <a:solidFill>
-                  <a:srgbClr val="000000"/>
-                </a:solidFill>
-                <a:latin typeface="Open Sauce"/>
-                <a:ea typeface="Open Sauce"/>
-                <a:cs typeface="Open Sauce"/>
-                <a:sym typeface="Open Sauce"/>
-              </a:rPr>
-              <a:t>Next JS</a:t>
-            </a:r>
-          </a:p>
-          <a:p>
-            <a:pPr algn="just" marL="528572" indent="-264286" lvl="1">
-              <a:lnSpc>
-                <a:spcPts val="3427"/>
-              </a:lnSpc>
-              <a:buFont typeface="Arial"/>
-              <a:buChar char="•"/>
-            </a:pPr>
-            <a:r>
-              <a:rPr lang="en-US" sz="2448">
-                <a:solidFill>
-                  <a:srgbClr val="000000"/>
-                </a:solidFill>
-                <a:latin typeface="Open Sauce"/>
-                <a:ea typeface="Open Sauce"/>
-                <a:cs typeface="Open Sauce"/>
-                <a:sym typeface="Open Sauce"/>
-              </a:rPr>
-              <a:t>Tailwind CSS</a:t>
-            </a:r>
-          </a:p>
-          <a:p>
-            <a:pPr algn="just" marL="528572" indent="-264286" lvl="1">
-              <a:lnSpc>
-                <a:spcPts val="3427"/>
-              </a:lnSpc>
-              <a:buFont typeface="Arial"/>
-              <a:buChar char="•"/>
-            </a:pPr>
-            <a:r>
-              <a:rPr lang="en-US" sz="2448">
-                <a:solidFill>
-                  <a:srgbClr val="000000"/>
-                </a:solidFill>
-                <a:latin typeface="Open Sauce"/>
-                <a:ea typeface="Open Sauce"/>
-                <a:cs typeface="Open Sauce"/>
-                <a:sym typeface="Open Sauce"/>
-              </a:rPr>
-              <a:t>Lucid icons</a:t>
-            </a:r>
-          </a:p>
-          <a:p>
-            <a:pPr algn="just" marL="528572" indent="-264286" lvl="1">
-              <a:lnSpc>
-                <a:spcPts val="3427"/>
-              </a:lnSpc>
-              <a:spcBef>
-                <a:spcPct val="0"/>
-              </a:spcBef>
-              <a:buFont typeface="Arial"/>
-              <a:buChar char="•"/>
-            </a:pPr>
-            <a:r>
-              <a:rPr lang="en-US" sz="2448">
-                <a:solidFill>
-                  <a:srgbClr val="000000"/>
-                </a:solidFill>
-                <a:latin typeface="Open Sauce"/>
-                <a:ea typeface="Open Sauce"/>
-                <a:cs typeface="Open Sauce"/>
-                <a:sym typeface="Open Sauce"/>
-              </a:rPr>
-              <a:t>GSAP</a:t>
-            </a:r>
-          </a:p>
-        </p:txBody>
-      </p:sp>
-      <p:sp>
-        <p:nvSpPr>
-          <p:cNvPr name="TextBox 6" id="6"/>
-          <p:cNvSpPr txBox="true"/>
-          <p:nvPr/>
-        </p:nvSpPr>
-        <p:spPr>
-          <a:xfrm rot="0">
-            <a:off x="11531891" y="5095875"/>
-            <a:ext cx="2574228" cy="415948"/>
-          </a:xfrm>
-          <a:prstGeom prst="rect">
-            <a:avLst/>
-          </a:prstGeom>
-        </p:spPr>
-        <p:txBody>
-          <a:bodyPr anchor="t" rtlCol="false" tIns="0" lIns="0" bIns="0" rIns="0">
-            <a:spAutoFit/>
-          </a:bodyPr>
-          <a:lstStyle/>
-          <a:p>
-            <a:pPr algn="ctr">
-              <a:lnSpc>
-                <a:spcPts val="3427"/>
-              </a:lnSpc>
-              <a:spcBef>
-                <a:spcPct val="0"/>
-              </a:spcBef>
-            </a:pPr>
-            <a:r>
-              <a:rPr lang="en-US" sz="2448">
-                <a:solidFill>
-                  <a:srgbClr val="8C7753"/>
-                </a:solidFill>
-                <a:latin typeface="Open Sauce"/>
-                <a:ea typeface="Open Sauce"/>
-                <a:cs typeface="Open Sauce"/>
-                <a:sym typeface="Open Sauce"/>
-              </a:rPr>
-              <a:t>Logiciels</a:t>
-            </a:r>
-            <a:r>
-              <a:rPr lang="en-US" sz="2448">
-                <a:solidFill>
-                  <a:srgbClr val="8C7753"/>
-                </a:solidFill>
-                <a:latin typeface="Open Sauce"/>
-                <a:ea typeface="Open Sauce"/>
-                <a:cs typeface="Open Sauce"/>
-                <a:sym typeface="Open Sauce"/>
-              </a:rPr>
-              <a:t> utilisés </a:t>
-            </a:r>
-          </a:p>
-        </p:txBody>
-      </p:sp>
-      <p:sp>
-        <p:nvSpPr>
-          <p:cNvPr name="TextBox 7" id="7"/>
-          <p:cNvSpPr txBox="true"/>
-          <p:nvPr/>
-        </p:nvSpPr>
-        <p:spPr>
-          <a:xfrm rot="0">
-            <a:off x="11531891" y="5559561"/>
-            <a:ext cx="1939527" cy="1276964"/>
-          </a:xfrm>
-          <a:prstGeom prst="rect">
-            <a:avLst/>
-          </a:prstGeom>
-        </p:spPr>
-        <p:txBody>
-          <a:bodyPr anchor="t" rtlCol="false" tIns="0" lIns="0" bIns="0" rIns="0">
-            <a:spAutoFit/>
-          </a:bodyPr>
-          <a:lstStyle/>
-          <a:p>
-            <a:pPr algn="l" marL="528572" indent="-264286" lvl="1">
-              <a:lnSpc>
-                <a:spcPts val="3427"/>
-              </a:lnSpc>
-              <a:buFont typeface="Arial"/>
-              <a:buChar char="•"/>
-            </a:pPr>
-            <a:r>
-              <a:rPr lang="en-US" sz="2448">
-                <a:solidFill>
-                  <a:srgbClr val="000000"/>
-                </a:solidFill>
-                <a:latin typeface="Open Sauce"/>
-                <a:ea typeface="Open Sauce"/>
-                <a:cs typeface="Open Sauce"/>
-                <a:sym typeface="Open Sauce"/>
-              </a:rPr>
-              <a:t>VS CODE</a:t>
-            </a:r>
-          </a:p>
-          <a:p>
-            <a:pPr algn="l" marL="528572" indent="-264286" lvl="1">
-              <a:lnSpc>
-                <a:spcPts val="3427"/>
-              </a:lnSpc>
-              <a:buFont typeface="Arial"/>
-              <a:buChar char="•"/>
-            </a:pPr>
-            <a:r>
-              <a:rPr lang="en-US" sz="2448">
-                <a:solidFill>
-                  <a:srgbClr val="000000"/>
-                </a:solidFill>
-                <a:latin typeface="Open Sauce"/>
-                <a:ea typeface="Open Sauce"/>
-                <a:cs typeface="Open Sauce"/>
-                <a:sym typeface="Open Sauce"/>
-              </a:rPr>
-              <a:t>Trello</a:t>
-            </a:r>
-          </a:p>
-          <a:p>
-            <a:pPr algn="l" marL="528572" indent="-264286" lvl="1">
-              <a:lnSpc>
-                <a:spcPts val="3427"/>
-              </a:lnSpc>
-              <a:spcBef>
-                <a:spcPct val="0"/>
-              </a:spcBef>
-              <a:buFont typeface="Arial"/>
-              <a:buChar char="•"/>
-            </a:pPr>
-            <a:r>
-              <a:rPr lang="en-US" sz="2448">
-                <a:solidFill>
-                  <a:srgbClr val="000000"/>
-                </a:solidFill>
-                <a:latin typeface="Open Sauce"/>
-                <a:ea typeface="Open Sauce"/>
-                <a:cs typeface="Open Sauce"/>
-                <a:sym typeface="Open Sauce"/>
-              </a:rPr>
-              <a:t>Github</a:t>
-            </a:r>
-          </a:p>
-        </p:txBody>
-      </p:sp>
-      <p:sp>
-        <p:nvSpPr>
-          <p:cNvPr name="TextBox 8" id="8"/>
-          <p:cNvSpPr txBox="true"/>
-          <p:nvPr/>
-        </p:nvSpPr>
-        <p:spPr>
-          <a:xfrm rot="0">
-            <a:off x="11531891" y="7106688"/>
-            <a:ext cx="4064413" cy="415948"/>
-          </a:xfrm>
-          <a:prstGeom prst="rect">
-            <a:avLst/>
-          </a:prstGeom>
-        </p:spPr>
-        <p:txBody>
-          <a:bodyPr anchor="t" rtlCol="false" tIns="0" lIns="0" bIns="0" rIns="0">
-            <a:spAutoFit/>
-          </a:bodyPr>
-          <a:lstStyle/>
-          <a:p>
-            <a:pPr algn="just">
-              <a:lnSpc>
-                <a:spcPts val="3427"/>
-              </a:lnSpc>
-              <a:spcBef>
-                <a:spcPct val="0"/>
-              </a:spcBef>
-            </a:pPr>
-            <a:r>
-              <a:rPr lang="en-US" sz="2448">
-                <a:solidFill>
-                  <a:srgbClr val="8C7753"/>
-                </a:solidFill>
-                <a:latin typeface="Open Sauce"/>
-                <a:ea typeface="Open Sauce"/>
-                <a:cs typeface="Open Sauce"/>
-                <a:sym typeface="Open Sauce"/>
-              </a:rPr>
-              <a:t>Moyens de communication</a:t>
-            </a:r>
-          </a:p>
-        </p:txBody>
-      </p:sp>
-      <p:sp>
-        <p:nvSpPr>
-          <p:cNvPr name="TextBox 9" id="9"/>
-          <p:cNvSpPr txBox="true"/>
-          <p:nvPr/>
-        </p:nvSpPr>
-        <p:spPr>
-          <a:xfrm rot="0">
-            <a:off x="11618516" y="7661497"/>
-            <a:ext cx="1690341" cy="846456"/>
-          </a:xfrm>
-          <a:prstGeom prst="rect">
-            <a:avLst/>
-          </a:prstGeom>
-        </p:spPr>
-        <p:txBody>
-          <a:bodyPr anchor="t" rtlCol="false" tIns="0" lIns="0" bIns="0" rIns="0">
-            <a:spAutoFit/>
-          </a:bodyPr>
-          <a:lstStyle/>
-          <a:p>
-            <a:pPr algn="just" marL="528572" indent="-264286" lvl="1">
-              <a:lnSpc>
-                <a:spcPts val="3427"/>
-              </a:lnSpc>
-              <a:buFont typeface="Arial"/>
-              <a:buChar char="•"/>
-            </a:pPr>
-            <a:r>
-              <a:rPr lang="en-US" sz="2448">
-                <a:solidFill>
-                  <a:srgbClr val="000000"/>
-                </a:solidFill>
-                <a:latin typeface="Open Sauce"/>
-                <a:ea typeface="Open Sauce"/>
-                <a:cs typeface="Open Sauce"/>
-                <a:sym typeface="Open Sauce"/>
-              </a:rPr>
-              <a:t>Discord</a:t>
-            </a:r>
-          </a:p>
-          <a:p>
-            <a:pPr algn="just">
-              <a:lnSpc>
-                <a:spcPts val="3427"/>
-              </a:lnSpc>
-              <a:spcBef>
-                <a:spcPct val="0"/>
-              </a:spcBef>
-            </a:pPr>
-          </a:p>
-        </p:txBody>
-      </p:sp>
-    </p:spTree>
-  </p:cSld>
-  <p:clrMapOvr>
-    <a:masterClrMapping/>
-  </p:clrMapOvr>
-  <p:transition spd="slow">
-    <p:push dir="l"/>
-  </p:transition>
-</p:sld>
-</file>
-
-<file path=ppt/slides/slide5.xml><?xml version="1.0" encoding="utf-8"?>
-<p:sld xmlns:p="http://schemas.openxmlformats.org/presentationml/2006/main" xmlns:a="http://schemas.openxmlformats.org/drawingml/2006/main">
-  <p:cSld>
-    <p:bg>
-      <p:bgPr>
-        <a:solidFill>
-          <a:srgbClr val="FAF7F0"/>
-        </a:solidFill>
-      </p:bgPr>
-    </p:bg>
-    <p:spTree>
-      <p:nvGrpSpPr>
-        <p:cNvPr id="1" name=""/>
-        <p:cNvGrpSpPr/>
-        <p:nvPr/>
-      </p:nvGrpSpPr>
-      <p:grpSpPr>
-        <a:xfrm>
-          <a:off x="0" y="0"/>
-          <a:ext cx="0" cy="0"/>
-          <a:chOff x="0" y="0"/>
-          <a:chExt cx="0" cy="0"/>
-        </a:xfrm>
-      </p:grpSpPr>
-      <p:sp>
-        <p:nvSpPr>
-          <p:cNvPr name="TextBox 2" id="2"/>
-          <p:cNvSpPr txBox="true"/>
-          <p:nvPr/>
-        </p:nvSpPr>
-        <p:spPr>
-          <a:xfrm rot="0">
-            <a:off x="933450" y="2696608"/>
-            <a:ext cx="10910528" cy="1735035"/>
-          </a:xfrm>
-          <a:prstGeom prst="rect">
-            <a:avLst/>
-          </a:prstGeom>
-        </p:spPr>
-        <p:txBody>
-          <a:bodyPr anchor="t" rtlCol="false" tIns="0" lIns="0" bIns="0" rIns="0">
+          <a:bodyPr lIns="0" tIns="0" rIns="0" bIns="0" rtlCol="0" anchor="t">
             <a:spAutoFit/>
           </a:bodyPr>
           <a:lstStyle/>
@@ -6609,12 +6792,12 @@
       </p:sp>
       <p:sp>
         <p:nvSpPr>
-          <p:cNvPr name="TextBox 3" id="3"/>
-          <p:cNvSpPr txBox="true"/>
+          <p:cNvPr id="3" name="TextBox 3"/>
+          <p:cNvSpPr txBox="1"/>
           <p:nvPr/>
         </p:nvSpPr>
         <p:spPr>
-          <a:xfrm rot="0">
+          <a:xfrm>
             <a:off x="9847827" y="7369021"/>
             <a:ext cx="7411473" cy="327660"/>
           </a:xfrm>
@@ -6623,7 +6806,7 @@
           </a:prstGeom>
         </p:spPr>
         <p:txBody>
-          <a:bodyPr anchor="t" rtlCol="false" tIns="0" lIns="0" bIns="0" rIns="0">
+          <a:bodyPr lIns="0" tIns="0" rIns="0" bIns="0" rtlCol="0" anchor="t">
             <a:spAutoFit/>
           </a:bodyPr>
           <a:lstStyle/>
@@ -6637,7 +6820,7 @@
               </a:spcBef>
             </a:pPr>
             <a:r>
-              <a:rPr lang="en-US" b="true" sz="2400" spc="240">
+              <a:rPr lang="en-US" sz="2400" b="1" spc="240">
                 <a:solidFill>
                   <a:srgbClr val="8C7753"/>
                 </a:solidFill>
@@ -6653,12 +6836,12 @@
       </p:sp>
       <p:sp>
         <p:nvSpPr>
-          <p:cNvPr name="TextBox 4" id="4"/>
-          <p:cNvSpPr txBox="true"/>
+          <p:cNvPr id="4" name="TextBox 4"/>
+          <p:cNvSpPr txBox="1"/>
           <p:nvPr/>
         </p:nvSpPr>
         <p:spPr>
-          <a:xfrm rot="0">
+          <a:xfrm>
             <a:off x="1028700" y="1057275"/>
             <a:ext cx="4560684" cy="245745"/>
           </a:xfrm>
@@ -6667,7 +6850,7 @@
           </a:prstGeom>
         </p:spPr>
         <p:txBody>
-          <a:bodyPr anchor="t" rtlCol="false" tIns="0" lIns="0" bIns="0" rIns="0">
+          <a:bodyPr lIns="0" tIns="0" rIns="0" bIns="0" rtlCol="0" anchor="t">
             <a:spAutoFit/>
           </a:bodyPr>
           <a:lstStyle/>
@@ -6681,7 +6864,7 @@
               </a:spcBef>
             </a:pPr>
             <a:r>
-              <a:rPr lang="en-US" b="true" sz="1800" spc="179">
+              <a:rPr lang="en-US" sz="1800" b="1" spc="179">
                 <a:solidFill>
                   <a:srgbClr val="8C7753"/>
                 </a:solidFill>
@@ -6701,7 +6884,7 @@
     <a:masterClrMapping/>
   </p:clrMapOvr>
   <p:transition spd="slow">
-    <p:push dir="l"/>
+    <p:push/>
   </p:transition>
 </p:sld>
 </file>

</xml_diff>